<commit_message>
Deck: tranche durations sum to the six-month maximum (45 + 60 + 75 days)
Co-Authored-By: Claude Fable 5.1 <noreply@anthropic.com>
Claude-Session: https://claude.ai/code/session_01LK5ScXv53crAietdRhpUqv
</commit_message>
<xml_diff>
--- a/docs/deck/kumbara-deck-hackathon.pptx
+++ b/docs/deck/kumbara-deck-hackathon.pptx
@@ -665,13 +665,13 @@
           <a:lstStyle/>
           <a:p>
             <a:r>
-              <a:t>TR: Üç dilim, altı ay. Birincisi zemin: SEP'e hazır anchor seçimi, Audit Bank başvurusu, relay bütçeleri, dağıtım belgeleri. İkincisi test ağı tam ve güvenli: STRIDE tehdit modeli, izleme planı, denetim ve düzeltmeler. Üçüncüsü ana ağ ve açık pilot; ölçüt kasadaki NAV, otuz gün. Her satırın maliyeti ve doğrulaması ekranda.</a:t>
+              <a:t>TR: Üç dilim, toplam altı ay. Birincisi zemin: SEP'e hazır anchor seçimi, Audit Bank başvurusu, relay bütçeleri, dağıtım belgeleri. İkincisi test ağı tam ve güvenli: STRIDE tehdit modeli, izleme planı, denetim ve düzeltmeler. Üçüncüsü ana ağ ve açık pilot; ölçüt kasadaki NAV, otuz gün. Her satırın maliyeti ve doğrulaması ekranda.</a:t>
             </a:r>
           </a:p>
           <a:p/>
           <a:p>
             <a:r>
-              <a:t>EN: Three tranches, six months. First, groundwork: a SEP-ready anchor chosen, the Audit Bank application, relay budgets, deployment docs. Second, testnet-complete and secured: STRIDE threat model, monitoring plan, audit and fixes. Third, mainnet launch and public pilot; the metric is vault NAV over thirty days. Every line has a cost and a way to verify it.</a:t>
+              <a:t>EN: Three tranches, six months in total. First, groundwork: a SEP-ready anchor chosen, the Audit Bank application, relay budgets, deployment docs. Second, testnet-complete and secured: STRIDE threat model, monitoring plan, audit and fixes. Third, mainnet launch and public pilot; the metric is vault NAV over thirty days. Every line has a cost and a way to verify it.</a:t>
             </a:r>
           </a:p>
         </p:txBody>

</xml_diff>

<commit_message>
Deck: nothing self-funded, no placeholders; regulation as a Tranche 1 market go/no-go
- Slide 8: non-custodial posture plus "where it launches": Türkiye first by fit; a Tranche 1
  go/no-go scores candidate markets on a licensed Stellar anchor with SEP rails and rules that
  allow a non-custodial savings app; if Türkiye fails, the pilot launches in the next market that
  passes, same app, different anchor.
- Slide 10: concrete USD lines (total $77,000), threshold set to an average daily NAV of
  5,000 USDC over the 30-day window (panel ratifies or adjusts), no self-funded box; a budget
  hygiene note lists what is deliberately not in the ask. Notes updated.

Co-Authored-By: Claude Fable 5.1 <noreply@anthropic.com>
Claude-Session: https://claude.ai/code/session_01LK5ScXv53crAietdRhpUqv
</commit_message>
<xml_diff>
--- a/docs/deck/kumbara-deck-hackathon.pptx
+++ b/docs/deck/kumbara-deck-hackathon.pptx
@@ -665,13 +665,13 @@
           <a:lstStyle/>
           <a:p>
             <a:r>
-              <a:t>TR: Üç dilim, toplam altı ay. Birincisi zemin: SEP'e hazır anchor seçimi, Audit Bank başvurusu, relay bütçeleri, dağıtım belgeleri. İkincisi test ağı tam ve güvenli: STRIDE tehdit modeli, izleme planı, denetim ve düzeltmeler. Üçüncüsü ana ağ ve açık pilot; ölçüt kasadaki NAV, otuz gün. Her satırın maliyeti ve doğrulaması ekranda.</a:t>
+              <a:t>TR: Üç dilim, toplam altı ay, yetmiş yedi bin dolar. Birincisi zemin: pazar ve anchor kararı, Audit Bank başvurusu, relay bütçeleri, dağıtım belgeleri. İkincisi test ağı tam ve güvenli: STRIDE tehdit modeli, izleme planı, denetim ve düzeltmeler. Üçüncüsü ana ağ ve açık pilot; ölçüt otuz günde ortalama beş bin USDC NAV. Her satırın maliyeti ve doğrulaması ekranda.</a:t>
             </a:r>
           </a:p>
           <a:p/>
           <a:p>
             <a:r>
-              <a:t>EN: Three tranches, six months in total. First, groundwork: a SEP-ready anchor chosen, the Audit Bank application, relay budgets, deployment docs. Second, testnet-complete and secured: STRIDE threat model, monitoring plan, audit and fixes. Third, mainnet launch and public pilot; the metric is vault NAV over thirty days. Every line has a cost and a way to verify it.</a:t>
+              <a:t>EN: Three tranches, six months, seventy-seven thousand dollars. First, groundwork: the market and anchor go/no-go, the Audit Bank application, relay budgets, deployment docs. Second, testnet-complete and secured: STRIDE threat model, monitoring plan, audit and fixes. Third, mainnet launch and public pilot; the metric is an average NAV of five thousand USDC over thirty days. Every line has a cost and check.</a:t>
             </a:r>
           </a:p>
         </p:txBody>
@@ -1349,13 +1349,13 @@
           <a:lstStyle/>
           <a:p>
             <a:r>
-              <a:t>TR: Kumbara emanet almayan bir yazılım: lira, USDC ya da anahtar tutmaz. Lisanslı anchor düzenlemeye tabi taraf; parayı o tutar, KYC'yi o yapar, kişinin kendi IBAN'ına öder. Türkiye'de ödeme özelliği yok. MASAK kuralları arayüzü şekillendirir. Türkiye hukuki görüşü kendi bütçemizden; ana ağ onu bekler.</a:t>
+              <a:t>TR: Kumbara emanet almayan bir yazılım: lira, USDC ya da anahtar tutmaz. Lisanslı anchor düzenlemeye tabi taraf; parayı o tutar, KYC'yi o yapar, kişinin kendi hesabına öder. Ödeme özelliği yok. Türkiye ilk aday; birinci dilimde pazar ve anchor için git/gitme kararı veririz. Türkiye geçemezse pilot, geçen bir sonraki pazarda açılır.</a:t>
             </a:r>
           </a:p>
           <a:p/>
           <a:p>
             <a:r>
-              <a:t>EN: Kumbara is non-custodial software: it never holds lira, USDC or keys. The licensed anchor is the regulated party; it holds the fiat, does KYC, and pays out to the person's own IBAN. No payments feature in Türkiye. MASAK rules shape the interface. The Turkish legal opinion is self-funded; mainnet waits for it.</a:t>
+              <a:t>EN: Kumbara is non-custodial software: it never holds lira, USDC or keys. The licensed anchor is the regulated party; it holds the fiat, does KYC, and pays out to the person's own account. No payments feature. Türkiye is the first candidate; Tranche 1 makes a market and anchor go/no-go. If Türkiye fails, the pilot launches in the next market that passes.</a:t>
             </a:r>
           </a:p>
         </p:txBody>

</xml_diff>

<commit_message>
Deck v3, frozen: one engineer at 60%, 60-day tranches, $54,810, anchor shortlist from the SCF Integration List
- Slide 10: hours x rate on every line ($70/h me, $55/h contractors), contractor
  sub-lines with a no-hire outcome, three 60-day tranches (handbook six-month
  maximum), total $54,810 (Medium band floor; $49,310 without the optional Expo
  line), metric justification 200 users x 50 USDC x 50% = 5,000 USDC, candidate
  anchors named only from the Integration List on/off-ramping section.
- Slide 8: regulatory gate is the selected anchor's written non-custodial
  position; anchor as a config choice; market class; market two as the follow-on award.
- Slide 2: market-class line; TÜİK citation wording tightened.
- Speaker notes for slides 2, 8, 10 updated (<=60 words each).

Co-Authored-By: Claude Fable 5.1 <noreply@anthropic.com>
Claude-Session: https://claude.ai/code/session_01LK5ScXv53crAietdRhpUqv
</commit_message>
<xml_diff>
--- a/docs/deck/kumbara-deck-hackathon.pptx
+++ b/docs/deck/kumbara-deck-hackathon.pptx
@@ -665,13 +665,13 @@
           <a:lstStyle/>
           <a:p>
             <a:r>
-              <a:t>TR: Üç dilim, toplam altı ay, yetmiş yedi bin dolar. Birincisi zemin: pazar ve anchor kararı, Audit Bank başvurusu, relay bütçeleri, dağıtım belgeleri. İkincisi test ağı tam ve güvenli: STRIDE tehdit modeli, izleme planı, denetim ve düzeltmeler. Üçüncüsü ana ağ ve açık pilot; ölçüt otuz günde ortalama beş bin USDC NAV. Her satırın maliyeti ve doğrulaması ekranda.</a:t>
+              <a:t>TR: Üç dilim, altmışar gün, toplam altı ay ve elli dört bin sekiz yüz on dolar: tek mühendis yüzde altmış zamanla, paralel işler için yüklenici saatleri ayrı satırlarda. Birincisi zemin: anchor kısa listesi ve git/gitme, Audit Bank başvurusu, relay bütçeleri. İkincisi tehdit modeli, izleme, denetim ve düzeltmeler. Üçüncüsü seçilen pilot pazarda ana ağ; ölçüt otuz günde ortalama beş bin USDC NAV.</a:t>
             </a:r>
           </a:p>
           <a:p/>
           <a:p>
             <a:r>
-              <a:t>EN: Three tranches, six months, seventy-seven thousand dollars. First, groundwork: the market and anchor go/no-go, the Audit Bank application, relay budgets, deployment docs. Second, testnet-complete and secured: STRIDE threat model, monitoring plan, audit and fixes. Third, mainnet launch and public pilot; the metric is an average NAV of five thousand USDC over thirty days. Every line has a cost and check.</a:t>
+              <a:t>EN: Three tranches of sixty days, six months, fifty-four thousand eight hundred ten dollars: one engineer at sixty percent, contractor hours on their own lines. First, groundwork: anchor shortlist and go/no-go, Audit Bank application, relay budgets. Second, threat model, monitoring, audit and fixes. Third, mainnet in the selected pilot market; the metric is five thousand USDC average NAV over thirty days.</a:t>
             </a:r>
           </a:p>
         </p:txBody>
@@ -817,13 +817,13 @@
           <a:lstStyle/>
           <a:p>
             <a:r>
-              <a:t>TR: TÜİK'e göre Ağustos'ta yıllık enflasyon yüzde 31,5. İnsanlar dolarda birikmek istiyor. Kripto yolu var ama önünde bir duvar: eklenti kur, on iki kelime yaz, gaz için XLM al, telefonu kaybetme. Her adımda kullanıcı kaybediyoruz; en çok ihtiyacı olan en az hizmet alıyor.</a:t>
+              <a:t>TR: TÜİK'e göre Ağustos'ta yıllık enflasyon yüzde 31,5. İnsanlar dolarda birikmek istiyor ama kripto yolunun önünde bir duvar var: eklenti, on iki kelime, gaz için XLM. Her adımda kullanıcı kaybediyoruz. Türkiye ilk pazar; ürün, banka havalesi alışkanlığı ve Stellar anchor'ı olan tüm yüksek enflasyonlu ekonomiler için yapıldı.</a:t>
             </a:r>
           </a:p>
           <a:p/>
           <a:p>
             <a:r>
-              <a:t>EN: Per TÜİK, annual inflation was 31.5 percent in August. People want to save in dollars. The crypto route exists, but a wall stands in front of it: install an extension, write twelve words, buy XLM for gas, never lose the phone. Every step sheds users; the people who need it most are served least.</a:t>
+              <a:t>EN: Per TÜİK, annual inflation was 31.5 percent in August. People want to save in dollars, but a wall stands in front of the crypto route: an extension, twelve words, XLM for gas. Every step sheds users. Türkiye is market one; the product is built for every high-inflation economy with a bank-transfer habit and a Stellar anchor.</a:t>
             </a:r>
           </a:p>
         </p:txBody>
@@ -1349,13 +1349,13 @@
           <a:lstStyle/>
           <a:p>
             <a:r>
-              <a:t>TR: Kumbara emanet almayan bir yazılım: lira, USDC ya da anahtar tutmaz. Lisanslı anchor düzenlemeye tabi taraf; parayı o tutar, KYC'yi o yapar, kişinin kendi hesabına öder. Ödeme özelliği yok. Türkiye ilk aday; birinci dilimde pazar ve anchor için git/gitme kararı veririz. Türkiye geçemezse pilot, geçen bir sonraki pazarda açılır.</a:t>
+              <a:t>TR: Kumbara emanet almayan bir yazılım: lira, USDC ya da anahtar tutmaz; lisanslı anchor düzenlemeye tabi taraf. Anchor bir yapılandırma seçimi: stellar.toml, SEP rayları, anchor'dan bağımsız köprü hesapları. Türkiye uyumdan ötürü ilk pazar; birinci dilim SCF listesindeki anchor'ları sıralar. Türkiye geçemezse pilot en üstteki pazarda açılır. İkinci pazar, ölçüt tutunca sonraki ödülün işi.</a:t>
             </a:r>
           </a:p>
           <a:p/>
           <a:p>
             <a:r>
-              <a:t>EN: Kumbara is non-custodial software: it never holds lira, USDC or keys. The licensed anchor is the regulated party; it holds the fiat, does KYC, and pays out to the person's own account. No payments feature. Türkiye is the first candidate; Tranche 1 makes a market and anchor go/no-go. If Türkiye fails, the pilot launches in the next market that passes.</a:t>
+              <a:t>EN: Kumbara is non-custodial software: it never holds lira, USDC or keys; the licensed anchor is the regulated party. The anchor is a config choice: stellar.toml, SEP rails, anchor-agnostic bridge accounts. Türkiye is market one by fit; Tranche 1 ranks the anchors on the SCF list. If Türkiye fails, the pilot launches in the top-ranked market; market two is the follow-on award.</a:t>
             </a:r>
           </a:p>
         </p:txBody>

</xml_diff>

<commit_message>
Hackathon deck, final: 8 slides for the Scale Track judges; passkey wording and fresh screenshots
- Hackathon variant: no SCF material (header, regulatory, team, roadmap,
  budget, metric, appendices hidden); title carries the team line; slide 7
  footnotes Reflector as a read-only mainnet oracle and cites the skills used;
  slide 8 adds the what's-next strip. Sequence-diagram appendix removed; the
  build requires Mermaid only where a diagram is visible.
- Both variants: 'Face ID' wording replaced by passkey (Face ID, Touch ID or a
  password manager); app screenshots re-captured on production; sup >= 15px.
- Page checks: zero overlapping text (footers and citations now included), no
  body text under 11pt, no wrapped footer. SCF 12 slides 1.95 MB; hackathon
  8 slides 1.43 MB. Speaker notes for the 8-slide deck, PPTX order updated.

Co-Authored-By: Claude Fable 5.1 <noreply@anthropic.com>
Claude-Session: https://claude.ai/code/session_01LK5ScXv53crAietdRhpUqv
</commit_message>
<xml_diff>
--- a/docs/deck/kumbara-deck-hackathon.pptx
+++ b/docs/deck/kumbara-deck-hackathon.pptx
@@ -13,12 +13,6 @@
     <p:sldId id="261" r:id="rId13"/>
     <p:sldId id="262" r:id="rId14"/>
     <p:sldId id="263" r:id="rId15"/>
-    <p:sldId id="264" r:id="rId16"/>
-    <p:sldId id="265" r:id="rId17"/>
-    <p:sldId id="266" r:id="rId18"/>
-    <p:sldId id="267" r:id="rId19"/>
-    <p:sldId id="268" r:id="rId20"/>
-    <p:sldId id="269" r:id="rId21"/>
   </p:sldIdLst>
   <p:sldSz cx="12191695" cy="6858000" type="screen4x3"/>
   <p:notesSz cx="6858000" cy="9144000"/>
@@ -515,393 +509,13 @@
           <a:lstStyle/>
           <a:p>
             <a:r>
-              <a:t>TR: Merhaba, ben Ahmed. Kumbara, Türkiye için Face ID ile açılan, anahtarı yalnızca sende olan bir dolar kumbarası. Lira gönderirsin, USDC olarak birikir, istediğinde liraya geri çekersin. Bugün göstereceğim her şey Stellar test ağında; gerçek lira hareket etmiyor.</a:t>
+              <a:t>TR: Merhaba, ben Ahmed: Instaward hibesi aldım, passkey-react kütüphanesini yazdım, smart-account-kit'e katkı verdim. Kumbara, Türkiye için Face ID ile açılan, anahtarı yalnızca sende olan bir dolar kumbarası. Lira gönderirsin, USDC olarak birikir, istediğinde liraya geri çekersin. Bugün göstereceğim her şey Stellar test ağında; gerçek lira hareket etmiyor.</a:t>
             </a:r>
           </a:p>
           <a:p/>
           <a:p>
             <a:r>
-              <a:t>EN: Hi, I'm Ahmed. Kumbara is a self-custodial dollar piggy bank for Türkiye that opens with Face ID. You send lira, it is held as USDC, and you take lira back whenever you like. Everything you will see today runs on Stellar testnet; no real lira moves.</a:t>
-            </a:r>
-          </a:p>
-        </p:txBody>
-      </p:sp>
-      <p:sp>
-        <p:nvSpPr>
-          <p:cNvPr id="4" name="Slide Number Placeholder 3"/>
-          <p:cNvSpPr>
-            <a:spLocks noGrp="1"/>
-          </p:cNvSpPr>
-          <p:nvPr>
-            <p:ph type="sldNum" idx="5" sz="quarter"/>
-          </p:nvPr>
-        </p:nvSpPr>
-        <p:spPr/>
-      </p:sp>
-    </p:spTree>
-  </p:cSld>
-  <p:clrMapOvr>
-    <a:masterClrMapping/>
-  </p:clrMapOvr>
-</p:notes>
-</file>
-
-<file path=ppt/notesSlides/notesSlide10.xml><?xml version="1.0" encoding="utf-8"?>
-<p:notes xmlns:a="http://schemas.openxmlformats.org/drawingml/2006/main" xmlns:p="http://schemas.openxmlformats.org/presentationml/2006/main" xmlns:r="http://schemas.openxmlformats.org/officeDocument/2006/relationships">
-  <p:cSld>
-    <p:spTree>
-      <p:nvGrpSpPr>
-        <p:cNvPr id="1" name=""/>
-        <p:cNvGrpSpPr/>
-        <p:nvPr/>
-      </p:nvGrpSpPr>
-      <p:grpSpPr>
-        <a:xfrm>
-          <a:off x="0" y="0"/>
-          <a:ext cx="0" cy="0"/>
-          <a:chOff x="0" y="0"/>
-          <a:chExt cx="0" cy="0"/>
-        </a:xfrm>
-      </p:grpSpPr>
-      <p:sp>
-        <p:nvSpPr>
-          <p:cNvPr id="2" name="Slide Image Placeholder 1"/>
-          <p:cNvSpPr>
-            <a:spLocks noGrp="1"/>
-          </p:cNvSpPr>
-          <p:nvPr>
-            <p:ph type="sldImg" idx="2"/>
-          </p:nvPr>
-        </p:nvSpPr>
-        <p:spPr/>
-      </p:sp>
-      <p:sp>
-        <p:nvSpPr>
-          <p:cNvPr id="3" name="Notes Placeholder 2"/>
-          <p:cNvSpPr>
-            <a:spLocks noGrp="1"/>
-          </p:cNvSpPr>
-          <p:nvPr>
-            <p:ph type="body" idx="3" sz="quarter"/>
-          </p:nvPr>
-        </p:nvSpPr>
-        <p:spPr/>
-        <p:txBody>
-          <a:bodyPr/>
-          <a:lstStyle/>
-          <a:p>
-            <a:r>
-              <a:t>TR: Tek kişilik bir ekip, ama üreten bir ekip. Instaward hibesi aldım, passkey-react kütüphanesini yazdım ve smart-account-kit'e birleşen bir düzeltme gönderdim. Kumbara'yı uçtan uca ben kurdum: uygulama, köprü hesapları, CI turları. Bağlantılar ekranda.</a:t>
-            </a:r>
-          </a:p>
-          <a:p/>
-          <a:p>
-            <a:r>
-              <a:t>EN: A team of one, but one that ships. I hold an Instaward grant, wrote the passkey-react library, and landed a fix in smart-account-kit. I built Kumbara end to end: the app, the bridge accounts, the CI round trips. Links are on the slide.</a:t>
-            </a:r>
-          </a:p>
-        </p:txBody>
-      </p:sp>
-      <p:sp>
-        <p:nvSpPr>
-          <p:cNvPr id="4" name="Slide Number Placeholder 3"/>
-          <p:cNvSpPr>
-            <a:spLocks noGrp="1"/>
-          </p:cNvSpPr>
-          <p:nvPr>
-            <p:ph type="sldNum" idx="5" sz="quarter"/>
-          </p:nvPr>
-        </p:nvSpPr>
-        <p:spPr/>
-      </p:sp>
-    </p:spTree>
-  </p:cSld>
-  <p:clrMapOvr>
-    <a:masterClrMapping/>
-  </p:clrMapOvr>
-</p:notes>
-</file>
-
-<file path=ppt/notesSlides/notesSlide11.xml><?xml version="1.0" encoding="utf-8"?>
-<p:notes xmlns:a="http://schemas.openxmlformats.org/drawingml/2006/main" xmlns:p="http://schemas.openxmlformats.org/presentationml/2006/main" xmlns:r="http://schemas.openxmlformats.org/officeDocument/2006/relationships">
-  <p:cSld>
-    <p:spTree>
-      <p:nvGrpSpPr>
-        <p:cNvPr id="1" name=""/>
-        <p:cNvGrpSpPr/>
-        <p:nvPr/>
-      </p:nvGrpSpPr>
-      <p:grpSpPr>
-        <a:xfrm>
-          <a:off x="0" y="0"/>
-          <a:ext cx="0" cy="0"/>
-          <a:chOff x="0" y="0"/>
-          <a:chExt cx="0" cy="0"/>
-        </a:xfrm>
-      </p:grpSpPr>
-      <p:sp>
-        <p:nvSpPr>
-          <p:cNvPr id="2" name="Slide Image Placeholder 1"/>
-          <p:cNvSpPr>
-            <a:spLocks noGrp="1"/>
-          </p:cNvSpPr>
-          <p:nvPr>
-            <p:ph type="sldImg" idx="2"/>
-          </p:nvPr>
-        </p:nvSpPr>
-        <p:spPr/>
-      </p:sp>
-      <p:sp>
-        <p:nvSpPr>
-          <p:cNvPr id="3" name="Notes Placeholder 2"/>
-          <p:cNvSpPr>
-            <a:spLocks noGrp="1"/>
-          </p:cNvSpPr>
-          <p:nvPr>
-            <p:ph type="body" idx="3" sz="quarter"/>
-          </p:nvPr>
-        </p:nvSpPr>
-        <p:spPr/>
-        <p:txBody>
-          <a:bodyPr/>
-          <a:lstStyle/>
-          <a:p>
-            <a:r>
-              <a:t>TR: Üç dilim, altmışar gün. Birincisi cüzdan katmanı ve relay sertleştirme, hepsi benim elimde: tek işlemle açılış, passkey-react 0.4, relay ana ağ sertleştirmesi, anchor kısa listesi ve git/gitme. İkincisi seçilen anchor bağlı, STRIDE tehdit modeli, izleme, denetim ve düzeltmeler, kapalı ana ağ yolu. Üçüncüsü pilot pazarda ana ağ, elli ile yüz kişilik pilot, nöbet, otuz günlük ölçüt penceresi.</a:t>
-            </a:r>
-          </a:p>
-          <a:p/>
-          <a:p>
-            <a:r>
-              <a:t>EN: Three tranches of sixty days. First, wallet layer and relay hardening, all in my control: single-transaction onboarding, passkey-react 0.4, relay mainnet hardening, the anchor shortlist and go/no-go. Second, the selected anchor wired in, STRIDE threat model, monitoring, audit and fixes, a capped mainnet path. Third, mainnet in the pilot market, fifty to a hundred pilot users, the thirty-day window.</a:t>
-            </a:r>
-          </a:p>
-        </p:txBody>
-      </p:sp>
-      <p:sp>
-        <p:nvSpPr>
-          <p:cNvPr id="4" name="Slide Number Placeholder 3"/>
-          <p:cNvSpPr>
-            <a:spLocks noGrp="1"/>
-          </p:cNvSpPr>
-          <p:nvPr>
-            <p:ph type="sldNum" idx="5" sz="quarter"/>
-          </p:nvPr>
-        </p:nvSpPr>
-        <p:spPr/>
-      </p:sp>
-    </p:spTree>
-  </p:cSld>
-  <p:clrMapOvr>
-    <a:masterClrMapping/>
-  </p:clrMapOvr>
-</p:notes>
-</file>
-
-<file path=ppt/notesSlides/notesSlide12.xml><?xml version="1.0" encoding="utf-8"?>
-<p:notes xmlns:a="http://schemas.openxmlformats.org/drawingml/2006/main" xmlns:p="http://schemas.openxmlformats.org/presentationml/2006/main" xmlns:r="http://schemas.openxmlformats.org/officeDocument/2006/relationships">
-  <p:cSld>
-    <p:spTree>
-      <p:nvGrpSpPr>
-        <p:cNvPr id="1" name=""/>
-        <p:cNvGrpSpPr/>
-        <p:nvPr/>
-      </p:nvGrpSpPr>
-      <p:grpSpPr>
-        <a:xfrm>
-          <a:off x="0" y="0"/>
-          <a:ext cx="0" cy="0"/>
-          <a:chOff x="0" y="0"/>
-          <a:chExt cx="0" cy="0"/>
-        </a:xfrm>
-      </p:grpSpPr>
-      <p:sp>
-        <p:nvSpPr>
-          <p:cNvPr id="2" name="Slide Image Placeholder 1"/>
-          <p:cNvSpPr>
-            <a:spLocks noGrp="1"/>
-          </p:cNvSpPr>
-          <p:nvPr>
-            <p:ph type="sldImg" idx="2"/>
-          </p:nvPr>
-        </p:nvSpPr>
-        <p:spPr/>
-      </p:sp>
-      <p:sp>
-        <p:nvSpPr>
-          <p:cNvPr id="3" name="Notes Placeholder 2"/>
-          <p:cNvSpPr>
-            <a:spLocks noGrp="1"/>
-          </p:cNvSpPr>
-          <p:nvPr>
-            <p:ph type="body" idx="3" sz="quarter"/>
-          </p:nvPr>
-        </p:nvSpPr>
-        <p:spPr/>
-        <p:txBody>
-          <a:bodyPr/>
-          <a:lstStyle/>
-          <a:p>
-            <a:r>
-              <a:t>TR: Yüz yedi bin üç yüz dolar; her dolar saat. Tam zamanlı çalışıyorum, saatte doksan beş dolar, dilim başına üç yüz kırk saat. Yüklenici kapasitesi yüz altmış saat, saatte altmış beş dolar; hiçbir kapı işe alıma bağlı değil. Ölçüt: açılıştan sonraki otuz günde ortalama iki bin beş yüz USDC NAV; yüz kullanıcı, elli USDC, yüzde elli kalış.</a:t>
-            </a:r>
-          </a:p>
-          <a:p/>
-          <a:p>
-            <a:r>
-              <a:t>EN: One hundred seven thousand three hundred dollars, every dollar hours. I work full-time at ninety-five an hour, three hundred forty hours per tranche. Hired capacity is one hundred sixty hours at sixty-five; no gate depends on a hire. Metric: average NAV of two thousand five hundred USDC over the thirty days after launch; a hundred users, fifty USDC, half retained.</a:t>
-            </a:r>
-          </a:p>
-        </p:txBody>
-      </p:sp>
-      <p:sp>
-        <p:nvSpPr>
-          <p:cNvPr id="4" name="Slide Number Placeholder 3"/>
-          <p:cNvSpPr>
-            <a:spLocks noGrp="1"/>
-          </p:cNvSpPr>
-          <p:nvPr>
-            <p:ph type="sldNum" idx="5" sz="quarter"/>
-          </p:nvPr>
-        </p:nvSpPr>
-        <p:spPr/>
-      </p:sp>
-    </p:spTree>
-  </p:cSld>
-  <p:clrMapOvr>
-    <a:masterClrMapping/>
-  </p:clrMapOvr>
-</p:notes>
-</file>
-
-<file path=ppt/notesSlides/notesSlide13.xml><?xml version="1.0" encoding="utf-8"?>
-<p:notes xmlns:a="http://schemas.openxmlformats.org/drawingml/2006/main" xmlns:p="http://schemas.openxmlformats.org/presentationml/2006/main" xmlns:r="http://schemas.openxmlformats.org/officeDocument/2006/relationships">
-  <p:cSld>
-    <p:spTree>
-      <p:nvGrpSpPr>
-        <p:cNvPr id="1" name=""/>
-        <p:cNvGrpSpPr/>
-        <p:nvPr/>
-      </p:nvGrpSpPr>
-      <p:grpSpPr>
-        <a:xfrm>
-          <a:off x="0" y="0"/>
-          <a:ext cx="0" cy="0"/>
-          <a:chOff x="0" y="0"/>
-          <a:chExt cx="0" cy="0"/>
-        </a:xfrm>
-      </p:grpSpPr>
-      <p:sp>
-        <p:nvSpPr>
-          <p:cNvPr id="2" name="Slide Image Placeholder 1"/>
-          <p:cNvSpPr>
-            <a:spLocks noGrp="1"/>
-          </p:cNvSpPr>
-          <p:nvPr>
-            <p:ph type="sldImg" idx="2"/>
-          </p:nvPr>
-        </p:nvSpPr>
-        <p:spPr/>
-      </p:sp>
-      <p:sp>
-        <p:nvSpPr>
-          <p:cNvPr id="3" name="Notes Placeholder 2"/>
-          <p:cNvSpPr>
-            <a:spLocks noGrp="1"/>
-          </p:cNvSpPr>
-          <p:nvPr>
-            <p:ph type="body" idx="3" sz="quarter"/>
-          </p:nvPr>
-        </p:nvSpPr>
-        <p:spPr/>
-        <p:txBody>
-          <a:bodyPr/>
-          <a:lstStyle/>
-          <a:p>
-            <a:r>
-              <a:t>TR: Referans için tam sıra diyagramı: passkey'den ödemeye kadar her mesaj. Kumbara ile relay arasındaki her ok imzalı bir yetki; anchor'a giden her ok klasik bir ödeme; kasaya giden tek ok kullanıcının Face ID'si. Sorusu olan için sunum sonunda buradayım.</a:t>
-            </a:r>
-          </a:p>
-          <a:p/>
-          <a:p>
-            <a:r>
-              <a:t>EN: The full sequence diagram for reference: every message from the passkey to the payout. Each arrow between Kumbara and the relay is a signed authorization; each arrow to the anchor is a classic payment; the single arrow into the vault is the user's Face ID. I'm here after the session for questions.</a:t>
-            </a:r>
-          </a:p>
-        </p:txBody>
-      </p:sp>
-      <p:sp>
-        <p:nvSpPr>
-          <p:cNvPr id="4" name="Slide Number Placeholder 3"/>
-          <p:cNvSpPr>
-            <a:spLocks noGrp="1"/>
-          </p:cNvSpPr>
-          <p:nvPr>
-            <p:ph type="sldNum" idx="5" sz="quarter"/>
-          </p:nvPr>
-        </p:nvSpPr>
-        <p:spPr/>
-      </p:sp>
-    </p:spTree>
-  </p:cSld>
-  <p:clrMapOvr>
-    <a:masterClrMapping/>
-  </p:clrMapOvr>
-</p:notes>
-</file>
-
-<file path=ppt/notesSlides/notesSlide14.xml><?xml version="1.0" encoding="utf-8"?>
-<p:notes xmlns:a="http://schemas.openxmlformats.org/drawingml/2006/main" xmlns:p="http://schemas.openxmlformats.org/presentationml/2006/main" xmlns:r="http://schemas.openxmlformats.org/officeDocument/2006/relationships">
-  <p:cSld>
-    <p:spTree>
-      <p:nvGrpSpPr>
-        <p:cNvPr id="1" name=""/>
-        <p:cNvGrpSpPr/>
-        <p:nvPr/>
-      </p:nvGrpSpPr>
-      <p:grpSpPr>
-        <a:xfrm>
-          <a:off x="0" y="0"/>
-          <a:ext cx="0" cy="0"/>
-          <a:chOff x="0" y="0"/>
-          <a:chExt cx="0" cy="0"/>
-        </a:xfrm>
-      </p:grpSpPr>
-      <p:sp>
-        <p:nvSpPr>
-          <p:cNvPr id="2" name="Slide Image Placeholder 1"/>
-          <p:cNvSpPr>
-            <a:spLocks noGrp="1"/>
-          </p:cNvSpPr>
-          <p:nvPr>
-            <p:ph type="sldImg" idx="2"/>
-          </p:nvPr>
-        </p:nvSpPr>
-        <p:spPr/>
-      </p:sp>
-      <p:sp>
-        <p:nvSpPr>
-          <p:cNvPr id="3" name="Notes Placeholder 2"/>
-          <p:cNvSpPr>
-            <a:spLocks noGrp="1"/>
-          </p:cNvSpPr>
-          <p:nvPr>
-            <p:ph type="body" idx="3" sz="quarter"/>
-          </p:nvPr>
-        </p:nvSpPr>
-        <p:spPr/>
-        <p:txBody>
-          <a:bodyPr/>
-          <a:lstStyle/>
-          <a:p>
-            <a:r>
-              <a:t>TR: Referans için satır satır saatler: yirmi satır, bin yüz seksen saat. Her satırda kimin yaptığı, kaç saat, kaç dolar ve gözden geçirenlerin nasıl doğrulayacağı yazıyor. Yüklenici satırları ayrı işaretli; işe alım gelmezse satır faturalanmaz ve dilim benim satırlarımla kapanır.</a:t>
-            </a:r>
-          </a:p>
-          <a:p/>
-          <a:p>
-            <a:r>
-              <a:t>EN: Line-by-line hours for reference: twenty lines, one thousand one hundred eighty hours. Each line says who does it, how many hours, how many dollars and how reviewers verify it. Hired lines are marked separately; if a hire does not land, the line is unbilled and the tranche closes on my own lines.</a:t>
+              <a:t>EN: Hi, I'm Ahmed: Instaward grantee, author of passkey-react, contributor to smart-account-kit. Kumbara is a self-custodial dollar piggy bank for Türkiye that opens with Face ID. You send lira, it is held as USDC, and you take lira back whenever you like. Everything you will see today runs on Stellar testnet; no real lira moves.</a:t>
             </a:r>
           </a:p>
         </p:txBody>
@@ -1047,13 +661,13 @@
           <a:lstStyle/>
           <a:p>
             <a:r>
-              <a:t>TR: Dört ekran. Tek tuş, Face ID, on saniyede hesap; tohum kelime yok, XLM yok, kurulum yok. Kumbaram ekranı kasadaki USDC'yi ve lira karşılığını gösterir. Yükleme, bildiğin havale ekranı: IBAN ve açıklama. Çekim, liraya satış kuru ve kendi IBAN'ına ödeme.</a:t>
+              <a:t>TR: Dört ekran. Tek tuş, Face ID ya da Touch ID, on saniyede hesap; tohum kelime yok, XLM yok, kurulum yok. Kumbaram ekranı kasadaki USDC'yi ve lira karşılığını gösterir. Yükleme, bildiğin havale ekranı: IBAN ve açıklama. Çekim, liraya satış kuru ve kendi IBAN'ına ödeme.</a:t>
             </a:r>
           </a:p>
           <a:p/>
           <a:p>
             <a:r>
-              <a:t>EN: Four screens. One button, Face ID, an account in about ten seconds; no seed phrase, no XLM, no install. Savings shows USDC in the vault and its lira value. Deposit is the bank-transfer screen everyone knows: IBAN and a reference. Withdraw is a sell quote and a payout to your own IBAN.</a:t>
+              <a:t>EN: Four screens. One button, Face ID or Touch ID, an account in about ten seconds; no seed phrase, no XLM, no install. Savings shows USDC in the vault and its lira value. Deposit is the bank-transfer screen everyone knows: IBAN and a reference. Withdraw is a sell quote and a payout to your own IBAN.</a:t>
             </a:r>
           </a:p>
         </p:txBody>
@@ -1123,13 +737,13 @@
           <a:lstStyle/>
           <a:p>
             <a:r>
-              <a:t>TR: Şimdi deneyin: kodu okutun, Kumbaranı aç'a dokunun, Face ID. Hesabınız açıldı. Yükle deyin, yüz yazın; bankayı ben oynatıyorum, bir dakikaya USDC kasada. Çek deyin, lira IBAN'a döner. Kurulum yok, kelime yok, XLM yok. Test ağı, gerçek para değil. Sayaç arkamda.</a:t>
+              <a:t>TR: Şimdi deneyin: kodu okutun, Kumbaranı aç'a dokunun, Face ID ya da Touch ID. Hesabınız açıldı. Yükle deyin, yüz yazın; bankayı ben oynatıyorum, bir dakikaya USDC kasada. Çek deyin, lira IBAN'a döner. Kurulum yok, kelime yok, XLM yok. Test ağı, gerçek para değil. Sayaç arkamda.</a:t>
             </a:r>
           </a:p>
           <a:p/>
           <a:p>
             <a:r>
-              <a:t>EN: Try it now: scan, tap Kumbaranı aç, Face ID. Your account exists. Tap Yükle, enter one hundred; I play the bank, and in about a minute the USDC is in the vault. Tap Çek and the lira comes back to the IBAN. No install, no words, no XLM. Testnet, not real money. The counter is behind me.</a:t>
+              <a:t>EN: Try it now: scan, tap Kumbaranı aç, Face ID or Touch ID. Your account exists. Tap Yükle, enter one hundred; I play the bank, and in about a minute the USDC is in the vault. Tap Çek and the lira comes back to the IBAN. No install, no words, no XLM. Testnet, not real money. The counter is behind me.</a:t>
             </a:r>
           </a:p>
         </p:txBody>
@@ -1199,13 +813,13 @@
           <a:lstStyle/>
           <a:p>
             <a:r>
-              <a:t>TR: Yedi adım. Face ID ile bir OpenZeppelin akıllı hesabı açılır, ücreti relay öder. Harcama limiti zincire yazılır. Anchor IBAN verir, lira gelir, USDC'ye çevrilir ve köprü hesabına ödenir. Köprü USDC'yi kumbaraya iletir, kendini kapatır. Bir Face ID ile USDC DeFindex kasasına girer. Çekim aynı yolu tersten yürür.</a:t>
+              <a:t>TR: Yedi adım. Passkey ile bir OpenZeppelin akıllı hesabı açılır, ücreti relay öder. Harcama limiti zincire yazılır. Anchor IBAN verir, lira gelir, USDC'ye çevrilir ve köprü hesabına ödenir. Köprü USDC'yi kumbaraya iletir, kendini kapatır. Bir Face ID ile USDC DeFindex kasasına girer. Çekim aynı yolu tersten yürür.</a:t>
             </a:r>
           </a:p>
           <a:p/>
           <a:p>
             <a:r>
-              <a:t>EN: Seven steps. Face ID opens an OpenZeppelin smart account; the relay pays the fees. A spending limit is written on-chain. The anchor issues an IBAN, lira arrives, becomes USDC, and is paid to a bridge account. The bridge forwards it to the kumbara and closes itself. One Face ID puts the USDC in the DeFindex vault. Withdrawal runs backwards.</a:t>
+              <a:t>EN: Seven steps. A passkey opens an OpenZeppelin smart account; the relay pays the fees. A spending limit is written on-chain. The anchor issues an IBAN, lira arrives, becomes USDC, and is paid to a bridge account. The bridge forwards it to the kumbara and closes itself. One Face ID puts the USDC in the DeFindex vault. Withdrawal runs backwards.</a:t>
             </a:r>
           </a:p>
         </p:txBody>
@@ -1427,89 +1041,13 @@
           <a:lstStyle/>
           <a:p>
             <a:r>
-              <a:t>TR: Her şey herkese açık ve tekrar çalıştırılabilir. Altı gerçek tarayıcı turu CI'da, her gönderimde ve altı saatte bir üretime karşı. Yirmi beş hata durumu, her biri bir ekran. Lighthouse 94 ve üç kez 100. Kasa kurulumu, yatırma ve çekme işlem karmaları test ağında. Etkinlik sayıları 20 Eylül'den sonra.</a:t>
+              <a:t>TR: Her şey herkese açık ve tekrar çalıştırılabilir: altı gerçek tarayıcı turu CI'da, yirmi beş hata ekranı, Lighthouse 94 ve üç kez 100, kasa kurulum, yatırma ve çekme karmaları test ağında. Sırada: Sembol Cloud v0 ana ağda, Instaward üçüncü ay; anchor ortaklık görüşmeleri sürüyor; etkinlikten sonra SCF Integration Track başvurusu.</a:t>
             </a:r>
           </a:p>
           <a:p/>
           <a:p>
             <a:r>
-              <a:t>EN: Everything here is public and re-runnable. Six real-browser round trips in CI, on every push and every six hours against production. Twenty-five failure states, each a screen. Lighthouse 94 and three hundreds. Vault deploy, invest and divest hashes on testnet. The event numbers come after 20 September.</a:t>
-            </a:r>
-          </a:p>
-        </p:txBody>
-      </p:sp>
-      <p:sp>
-        <p:nvSpPr>
-          <p:cNvPr id="4" name="Slide Number Placeholder 3"/>
-          <p:cNvSpPr>
-            <a:spLocks noGrp="1"/>
-          </p:cNvSpPr>
-          <p:nvPr>
-            <p:ph type="sldNum" idx="5" sz="quarter"/>
-          </p:nvPr>
-        </p:nvSpPr>
-        <p:spPr/>
-      </p:sp>
-    </p:spTree>
-  </p:cSld>
-  <p:clrMapOvr>
-    <a:masterClrMapping/>
-  </p:clrMapOvr>
-</p:notes>
-</file>
-
-<file path=ppt/notesSlides/notesSlide9.xml><?xml version="1.0" encoding="utf-8"?>
-<p:notes xmlns:a="http://schemas.openxmlformats.org/drawingml/2006/main" xmlns:p="http://schemas.openxmlformats.org/presentationml/2006/main" xmlns:r="http://schemas.openxmlformats.org/officeDocument/2006/relationships">
-  <p:cSld>
-    <p:spTree>
-      <p:nvGrpSpPr>
-        <p:cNvPr id="1" name=""/>
-        <p:cNvGrpSpPr/>
-        <p:nvPr/>
-      </p:nvGrpSpPr>
-      <p:grpSpPr>
-        <a:xfrm>
-          <a:off x="0" y="0"/>
-          <a:ext cx="0" cy="0"/>
-          <a:chOff x="0" y="0"/>
-          <a:chExt cx="0" cy="0"/>
-        </a:xfrm>
-      </p:grpSpPr>
-      <p:sp>
-        <p:nvSpPr>
-          <p:cNvPr id="2" name="Slide Image Placeholder 1"/>
-          <p:cNvSpPr>
-            <a:spLocks noGrp="1"/>
-          </p:cNvSpPr>
-          <p:nvPr>
-            <p:ph type="sldImg" idx="2"/>
-          </p:nvPr>
-        </p:nvSpPr>
-        <p:spPr/>
-      </p:sp>
-      <p:sp>
-        <p:nvSpPr>
-          <p:cNvPr id="3" name="Notes Placeholder 2"/>
-          <p:cNvSpPr>
-            <a:spLocks noGrp="1"/>
-          </p:cNvSpPr>
-          <p:nvPr>
-            <p:ph type="body" idx="3" sz="quarter"/>
-          </p:nvPr>
-        </p:nvSpPr>
-        <p:spPr/>
-        <p:txBody>
-          <a:bodyPr/>
-          <a:lstStyle/>
-          <a:p>
-            <a:r>
-              <a:t>TR: Kumbara emanet almayan bir yazılım: lira, USDC ya da anahtar tutmaz; lisanslı anchor düzenlemeye tabi taraf. Anchor bir yapılandırma seçimi: stellar.toml, SEP rayları, anchor'dan bağımsız köprü hesapları. Türkiye uyumdan ötürü ilk pazar; birinci dilim SCF listesindeki anchor'ları sıralar. Türkiye geçemezse pilot en üstteki pazarda açılır. İkinci pazar, ölçüt tutunca sonraki ödülün işi.</a:t>
-            </a:r>
-          </a:p>
-          <a:p/>
-          <a:p>
-            <a:r>
-              <a:t>EN: Kumbara is non-custodial software: it never holds lira, USDC or keys; the licensed anchor is the regulated party. The anchor is a config choice: stellar.toml, SEP rails, anchor-agnostic bridge accounts. Türkiye is market one by fit; Tranche 1 ranks the anchors on the SCF list. If Türkiye fails, the pilot launches in the top-ranked market; market two is the follow-on.</a:t>
+              <a:t>EN: Everything here is public and re-runnable: six real-browser round trips in CI, twenty-five failure screens, Lighthouse 94 and three hundreds, the vault deploy, invest and divest hashes on testnet. Next: Sembol Cloud v0 on mainnet in Instaward Month 3, anchor partnership conversations underway, and the SCF Integration Track after the event.</a:t>
             </a:r>
           </a:p>
         </p:txBody>
@@ -4547,216 +4085,6 @@
 </p:sld>
 </file>
 
-<file path=ppt/slides/slide10.xml><?xml version="1.0" encoding="utf-8"?>
-<p:sld xmlns:a="http://schemas.openxmlformats.org/drawingml/2006/main" xmlns:p="http://schemas.openxmlformats.org/presentationml/2006/main" xmlns:r="http://schemas.openxmlformats.org/officeDocument/2006/relationships">
-  <p:cSld>
-    <p:spTree>
-      <p:nvGrpSpPr>
-        <p:cNvPr id="1" name=""/>
-        <p:cNvGrpSpPr/>
-        <p:nvPr/>
-      </p:nvGrpSpPr>
-      <p:grpSpPr/>
-      <p:pic>
-        <p:nvPicPr>
-          <p:cNvPr id="2" name="Picture 1" descr="slide-10.png"/>
-          <p:cNvPicPr>
-            <a:picLocks noChangeAspect="1"/>
-          </p:cNvPicPr>
-          <p:nvPr/>
-        </p:nvPicPr>
-        <p:blipFill>
-          <a:blip r:embed="rId2"/>
-          <a:stretch>
-            <a:fillRect/>
-          </a:stretch>
-        </p:blipFill>
-        <p:spPr>
-          <a:xfrm>
-            <a:off x="0" y="0"/>
-            <a:ext cx="12191695" cy="6858000"/>
-          </a:xfrm>
-          <a:prstGeom prst="rect">
-            <a:avLst/>
-          </a:prstGeom>
-        </p:spPr>
-      </p:pic>
-    </p:spTree>
-  </p:cSld>
-  <p:clrMapOvr>
-    <a:masterClrMapping/>
-  </p:clrMapOvr>
-</p:sld>
-</file>
-
-<file path=ppt/slides/slide11.xml><?xml version="1.0" encoding="utf-8"?>
-<p:sld xmlns:a="http://schemas.openxmlformats.org/drawingml/2006/main" xmlns:p="http://schemas.openxmlformats.org/presentationml/2006/main" xmlns:r="http://schemas.openxmlformats.org/officeDocument/2006/relationships">
-  <p:cSld>
-    <p:spTree>
-      <p:nvGrpSpPr>
-        <p:cNvPr id="1" name=""/>
-        <p:cNvGrpSpPr/>
-        <p:nvPr/>
-      </p:nvGrpSpPr>
-      <p:grpSpPr/>
-      <p:pic>
-        <p:nvPicPr>
-          <p:cNvPr id="2" name="Picture 1" descr="slide-11.png"/>
-          <p:cNvPicPr>
-            <a:picLocks noChangeAspect="1"/>
-          </p:cNvPicPr>
-          <p:nvPr/>
-        </p:nvPicPr>
-        <p:blipFill>
-          <a:blip r:embed="rId2"/>
-          <a:stretch>
-            <a:fillRect/>
-          </a:stretch>
-        </p:blipFill>
-        <p:spPr>
-          <a:xfrm>
-            <a:off x="0" y="0"/>
-            <a:ext cx="12191695" cy="6858000"/>
-          </a:xfrm>
-          <a:prstGeom prst="rect">
-            <a:avLst/>
-          </a:prstGeom>
-        </p:spPr>
-      </p:pic>
-    </p:spTree>
-  </p:cSld>
-  <p:clrMapOvr>
-    <a:masterClrMapping/>
-  </p:clrMapOvr>
-</p:sld>
-</file>
-
-<file path=ppt/slides/slide12.xml><?xml version="1.0" encoding="utf-8"?>
-<p:sld xmlns:a="http://schemas.openxmlformats.org/drawingml/2006/main" xmlns:p="http://schemas.openxmlformats.org/presentationml/2006/main" xmlns:r="http://schemas.openxmlformats.org/officeDocument/2006/relationships">
-  <p:cSld>
-    <p:spTree>
-      <p:nvGrpSpPr>
-        <p:cNvPr id="1" name=""/>
-        <p:cNvGrpSpPr/>
-        <p:nvPr/>
-      </p:nvGrpSpPr>
-      <p:grpSpPr/>
-      <p:pic>
-        <p:nvPicPr>
-          <p:cNvPr id="2" name="Picture 1" descr="slide-12.png"/>
-          <p:cNvPicPr>
-            <a:picLocks noChangeAspect="1"/>
-          </p:cNvPicPr>
-          <p:nvPr/>
-        </p:nvPicPr>
-        <p:blipFill>
-          <a:blip r:embed="rId2"/>
-          <a:stretch>
-            <a:fillRect/>
-          </a:stretch>
-        </p:blipFill>
-        <p:spPr>
-          <a:xfrm>
-            <a:off x="0" y="0"/>
-            <a:ext cx="12191695" cy="6858000"/>
-          </a:xfrm>
-          <a:prstGeom prst="rect">
-            <a:avLst/>
-          </a:prstGeom>
-        </p:spPr>
-      </p:pic>
-    </p:spTree>
-  </p:cSld>
-  <p:clrMapOvr>
-    <a:masterClrMapping/>
-  </p:clrMapOvr>
-</p:sld>
-</file>
-
-<file path=ppt/slides/slide13.xml><?xml version="1.0" encoding="utf-8"?>
-<p:sld xmlns:a="http://schemas.openxmlformats.org/drawingml/2006/main" xmlns:p="http://schemas.openxmlformats.org/presentationml/2006/main" xmlns:r="http://schemas.openxmlformats.org/officeDocument/2006/relationships">
-  <p:cSld>
-    <p:spTree>
-      <p:nvGrpSpPr>
-        <p:cNvPr id="1" name=""/>
-        <p:cNvGrpSpPr/>
-        <p:nvPr/>
-      </p:nvGrpSpPr>
-      <p:grpSpPr/>
-      <p:pic>
-        <p:nvPicPr>
-          <p:cNvPr id="2" name="Picture 1" descr="slide-13.png"/>
-          <p:cNvPicPr>
-            <a:picLocks noChangeAspect="1"/>
-          </p:cNvPicPr>
-          <p:nvPr/>
-        </p:nvPicPr>
-        <p:blipFill>
-          <a:blip r:embed="rId2"/>
-          <a:stretch>
-            <a:fillRect/>
-          </a:stretch>
-        </p:blipFill>
-        <p:spPr>
-          <a:xfrm>
-            <a:off x="0" y="0"/>
-            <a:ext cx="12191695" cy="6858000"/>
-          </a:xfrm>
-          <a:prstGeom prst="rect">
-            <a:avLst/>
-          </a:prstGeom>
-        </p:spPr>
-      </p:pic>
-    </p:spTree>
-  </p:cSld>
-  <p:clrMapOvr>
-    <a:masterClrMapping/>
-  </p:clrMapOvr>
-</p:sld>
-</file>
-
-<file path=ppt/slides/slide14.xml><?xml version="1.0" encoding="utf-8"?>
-<p:sld xmlns:a="http://schemas.openxmlformats.org/drawingml/2006/main" xmlns:p="http://schemas.openxmlformats.org/presentationml/2006/main" xmlns:r="http://schemas.openxmlformats.org/officeDocument/2006/relationships">
-  <p:cSld>
-    <p:spTree>
-      <p:nvGrpSpPr>
-        <p:cNvPr id="1" name=""/>
-        <p:cNvGrpSpPr/>
-        <p:nvPr/>
-      </p:nvGrpSpPr>
-      <p:grpSpPr/>
-      <p:pic>
-        <p:nvPicPr>
-          <p:cNvPr id="2" name="Picture 1" descr="slide-14.png"/>
-          <p:cNvPicPr>
-            <a:picLocks noChangeAspect="1"/>
-          </p:cNvPicPr>
-          <p:nvPr/>
-        </p:nvPicPr>
-        <p:blipFill>
-          <a:blip r:embed="rId2"/>
-          <a:stretch>
-            <a:fillRect/>
-          </a:stretch>
-        </p:blipFill>
-        <p:spPr>
-          <a:xfrm>
-            <a:off x="0" y="0"/>
-            <a:ext cx="12191695" cy="6858000"/>
-          </a:xfrm>
-          <a:prstGeom prst="rect">
-            <a:avLst/>
-          </a:prstGeom>
-        </p:spPr>
-      </p:pic>
-    </p:spTree>
-  </p:cSld>
-  <p:clrMapOvr>
-    <a:masterClrMapping/>
-  </p:clrMapOvr>
-</p:sld>
-</file>
-
 <file path=ppt/slides/slide2.xml><?xml version="1.0" encoding="utf-8"?>
 <p:sld xmlns:a="http://schemas.openxmlformats.org/drawingml/2006/main" xmlns:p="http://schemas.openxmlformats.org/presentationml/2006/main" xmlns:r="http://schemas.openxmlformats.org/officeDocument/2006/relationships">
   <p:cSld>
@@ -5022,48 +4350,6 @@
       <p:pic>
         <p:nvPicPr>
           <p:cNvPr id="2" name="Picture 1" descr="slide-08.png"/>
-          <p:cNvPicPr>
-            <a:picLocks noChangeAspect="1"/>
-          </p:cNvPicPr>
-          <p:nvPr/>
-        </p:nvPicPr>
-        <p:blipFill>
-          <a:blip r:embed="rId2"/>
-          <a:stretch>
-            <a:fillRect/>
-          </a:stretch>
-        </p:blipFill>
-        <p:spPr>
-          <a:xfrm>
-            <a:off x="0" y="0"/>
-            <a:ext cx="12191695" cy="6858000"/>
-          </a:xfrm>
-          <a:prstGeom prst="rect">
-            <a:avLst/>
-          </a:prstGeom>
-        </p:spPr>
-      </p:pic>
-    </p:spTree>
-  </p:cSld>
-  <p:clrMapOvr>
-    <a:masterClrMapping/>
-  </p:clrMapOvr>
-</p:sld>
-</file>
-
-<file path=ppt/slides/slide9.xml><?xml version="1.0" encoding="utf-8"?>
-<p:sld xmlns:a="http://schemas.openxmlformats.org/drawingml/2006/main" xmlns:p="http://schemas.openxmlformats.org/presentationml/2006/main" xmlns:r="http://schemas.openxmlformats.org/officeDocument/2006/relationships">
-  <p:cSld>
-    <p:spTree>
-      <p:nvGrpSpPr>
-        <p:cNvPr id="1" name=""/>
-        <p:cNvGrpSpPr/>
-        <p:nvPr/>
-      </p:nvGrpSpPr>
-      <p:grpSpPr/>
-      <p:pic>
-        <p:nvPicPr>
-          <p:cNvPr id="2" name="Picture 1" descr="slide-09.png"/>
           <p:cNvPicPr>
             <a:picLocks noChangeAspect="1"/>
           </p:cNvPicPr>

</xml_diff>

<commit_message>
Decks: PPTX rebuilt from the 17 September slides
The previous commit's PPTX files were unchanged (no generator was
available at the time); these are one full-bleed 1920×1080 image per
slide from docs/deck/slides-*, matching the PDFs.

Co-Authored-By: Claude Fable 5.1 <noreply@anthropic.com>
Claude-Session: https://claude.ai/code/session_01LK5ScXv53crAietdRhpUqv
</commit_message>
<xml_diff>
--- a/docs/deck/kumbara-deck-hackathon.pptx
+++ b/docs/deck/kumbara-deck-hackathon.pptx
@@ -6,13 +6,13 @@
   </p:sldMasterIdLst>
   <p:sldIdLst>
     <p:sldId id="256" r:id="rId7"/>
-    <p:sldId id="257" r:id="rId9"/>
-    <p:sldId id="258" r:id="rId10"/>
-    <p:sldId id="259" r:id="rId11"/>
-    <p:sldId id="260" r:id="rId12"/>
-    <p:sldId id="261" r:id="rId13"/>
-    <p:sldId id="262" r:id="rId14"/>
-    <p:sldId id="263" r:id="rId15"/>
+    <p:sldId id="257" r:id="rId8"/>
+    <p:sldId id="258" r:id="rId9"/>
+    <p:sldId id="259" r:id="rId10"/>
+    <p:sldId id="260" r:id="rId11"/>
+    <p:sldId id="261" r:id="rId12"/>
+    <p:sldId id="262" r:id="rId13"/>
+    <p:sldId id="263" r:id="rId14"/>
   </p:sldIdLst>
   <p:sldSz cx="12191695" cy="6858000" type="screen4x3"/>
   <p:notesSz cx="6858000" cy="9144000"/>
@@ -112,964 +112,6 @@
     </a:lvl9pPr>
   </p:defaultTextStyle>
 </p:presentation>
-</file>
-
-<file path=ppt/notesMasters/notesMaster1.xml><?xml version="1.0" encoding="utf-8"?>
-<p:notesMaster xmlns:a="http://schemas.openxmlformats.org/drawingml/2006/main" xmlns:p="http://schemas.openxmlformats.org/presentationml/2006/main" xmlns:r="http://schemas.openxmlformats.org/officeDocument/2006/relationships">
-  <p:cSld>
-    <p:bg>
-      <p:bgRef idx="1001">
-        <a:schemeClr val="bg1"/>
-      </p:bgRef>
-    </p:bg>
-    <p:spTree>
-      <p:nvGrpSpPr>
-        <p:cNvPr id="1" name=""/>
-        <p:cNvGrpSpPr/>
-        <p:nvPr/>
-      </p:nvGrpSpPr>
-      <p:grpSpPr>
-        <a:xfrm>
-          <a:off x="0" y="0"/>
-          <a:ext cx="0" cy="0"/>
-          <a:chOff x="0" y="0"/>
-          <a:chExt cx="0" cy="0"/>
-        </a:xfrm>
-      </p:grpSpPr>
-      <p:sp>
-        <p:nvSpPr>
-          <p:cNvPr id="2" name="Header Placeholder 1"/>
-          <p:cNvSpPr>
-            <a:spLocks noGrp="1"/>
-          </p:cNvSpPr>
-          <p:nvPr>
-            <p:ph type="hdr" sz="quarter"/>
-          </p:nvPr>
-        </p:nvSpPr>
-        <p:spPr>
-          <a:xfrm>
-            <a:off x="0" y="0"/>
-            <a:ext cx="2971800" cy="457200"/>
-          </a:xfrm>
-          <a:prstGeom prst="rect">
-            <a:avLst/>
-          </a:prstGeom>
-        </p:spPr>
-        <p:txBody>
-          <a:bodyPr vert="horz" lIns="91440" tIns="45720" rIns="91440" bIns="45720" rtlCol="0"/>
-          <a:lstStyle>
-            <a:lvl1pPr algn="l">
-              <a:defRPr sz="1200"/>
-            </a:lvl1pPr>
-          </a:lstStyle>
-          <a:p>
-            <a:endParaRPr lang="en-US"/>
-          </a:p>
-        </p:txBody>
-      </p:sp>
-      <p:sp>
-        <p:nvSpPr>
-          <p:cNvPr id="3" name="Date Placeholder 2"/>
-          <p:cNvSpPr>
-            <a:spLocks noGrp="1"/>
-          </p:cNvSpPr>
-          <p:nvPr>
-            <p:ph type="dt" idx="1"/>
-          </p:nvPr>
-        </p:nvSpPr>
-        <p:spPr>
-          <a:xfrm>
-            <a:off x="3884613" y="0"/>
-            <a:ext cx="2971800" cy="457200"/>
-          </a:xfrm>
-          <a:prstGeom prst="rect">
-            <a:avLst/>
-          </a:prstGeom>
-        </p:spPr>
-        <p:txBody>
-          <a:bodyPr vert="horz" lIns="91440" tIns="45720" rIns="91440" bIns="45720" rtlCol="0"/>
-          <a:lstStyle>
-            <a:lvl1pPr algn="r">
-              <a:defRPr sz="1200"/>
-            </a:lvl1pPr>
-          </a:lstStyle>
-          <a:p>
-            <a:fld id="{0F89C1C7-3DCD-1040-A9CF-14679D8B5DDD}" type="datetimeFigureOut">
-              <a:rPr lang="en-US" smtClean="0"/>
-              <a:t>10/17/16</a:t>
-            </a:fld>
-            <a:endParaRPr lang="en-US"/>
-          </a:p>
-        </p:txBody>
-      </p:sp>
-      <p:sp>
-        <p:nvSpPr>
-          <p:cNvPr id="4" name="Slide Image Placeholder 3"/>
-          <p:cNvSpPr>
-            <a:spLocks noGrp="1" noRot="1" noChangeAspect="1"/>
-          </p:cNvSpPr>
-          <p:nvPr>
-            <p:ph type="sldImg" idx="2"/>
-          </p:nvPr>
-        </p:nvSpPr>
-        <p:spPr>
-          <a:xfrm>
-            <a:off x="1143000" y="685800"/>
-            <a:ext cx="4572000" cy="3429000"/>
-          </a:xfrm>
-          <a:prstGeom prst="rect">
-            <a:avLst/>
-          </a:prstGeom>
-          <a:noFill/>
-          <a:ln w="12700">
-            <a:solidFill>
-              <a:prstClr val="black"/>
-            </a:solidFill>
-          </a:ln>
-        </p:spPr>
-        <p:txBody>
-          <a:bodyPr vert="horz" lIns="91440" tIns="45720" rIns="91440" bIns="45720" rtlCol="0" anchor="ctr"/>
-          <a:lstStyle/>
-          <a:p>
-            <a:endParaRPr lang="en-US"/>
-          </a:p>
-        </p:txBody>
-      </p:sp>
-      <p:sp>
-        <p:nvSpPr>
-          <p:cNvPr id="5" name="Notes Placeholder 4"/>
-          <p:cNvSpPr>
-            <a:spLocks noGrp="1"/>
-          </p:cNvSpPr>
-          <p:nvPr>
-            <p:ph type="body" sz="quarter" idx="3"/>
-          </p:nvPr>
-        </p:nvSpPr>
-        <p:spPr>
-          <a:xfrm>
-            <a:off x="685800" y="4343400"/>
-            <a:ext cx="5486400" cy="4114800"/>
-          </a:xfrm>
-          <a:prstGeom prst="rect">
-            <a:avLst/>
-          </a:prstGeom>
-        </p:spPr>
-        <p:txBody>
-          <a:bodyPr vert="horz" lIns="91440" tIns="45720" rIns="91440" bIns="45720" rtlCol="0"/>
-          <a:lstStyle/>
-          <a:p>
-            <a:pPr lvl="0"/>
-            <a:r>
-              <a:rPr lang="en-US" smtClean="0"/>
-              <a:t>Click to edit Master text styles</a:t>
-            </a:r>
-          </a:p>
-          <a:p>
-            <a:pPr lvl="1"/>
-            <a:r>
-              <a:rPr lang="en-US" smtClean="0"/>
-              <a:t>Second level</a:t>
-            </a:r>
-          </a:p>
-          <a:p>
-            <a:pPr lvl="2"/>
-            <a:r>
-              <a:rPr lang="en-US" smtClean="0"/>
-              <a:t>Third level</a:t>
-            </a:r>
-          </a:p>
-          <a:p>
-            <a:pPr lvl="3"/>
-            <a:r>
-              <a:rPr lang="en-US" smtClean="0"/>
-              <a:t>Fourth level</a:t>
-            </a:r>
-          </a:p>
-          <a:p>
-            <a:pPr lvl="4"/>
-            <a:r>
-              <a:rPr lang="en-US" smtClean="0"/>
-              <a:t>Fifth level</a:t>
-            </a:r>
-            <a:endParaRPr lang="en-US"/>
-          </a:p>
-        </p:txBody>
-      </p:sp>
-      <p:sp>
-        <p:nvSpPr>
-          <p:cNvPr id="6" name="Footer Placeholder 5"/>
-          <p:cNvSpPr>
-            <a:spLocks noGrp="1"/>
-          </p:cNvSpPr>
-          <p:nvPr>
-            <p:ph type="ftr" sz="quarter" idx="4"/>
-          </p:nvPr>
-        </p:nvSpPr>
-        <p:spPr>
-          <a:xfrm>
-            <a:off x="0" y="8685213"/>
-            <a:ext cx="2971800" cy="457200"/>
-          </a:xfrm>
-          <a:prstGeom prst="rect">
-            <a:avLst/>
-          </a:prstGeom>
-        </p:spPr>
-        <p:txBody>
-          <a:bodyPr vert="horz" lIns="91440" tIns="45720" rIns="91440" bIns="45720" rtlCol="0" anchor="b"/>
-          <a:lstStyle>
-            <a:lvl1pPr algn="l">
-              <a:defRPr sz="1200"/>
-            </a:lvl1pPr>
-          </a:lstStyle>
-          <a:p>
-            <a:endParaRPr lang="en-US"/>
-          </a:p>
-        </p:txBody>
-      </p:sp>
-      <p:sp>
-        <p:nvSpPr>
-          <p:cNvPr id="7" name="Slide Number Placeholder 6"/>
-          <p:cNvSpPr>
-            <a:spLocks noGrp="1"/>
-          </p:cNvSpPr>
-          <p:nvPr>
-            <p:ph type="sldNum" sz="quarter" idx="5"/>
-          </p:nvPr>
-        </p:nvSpPr>
-        <p:spPr>
-          <a:xfrm>
-            <a:off x="3884613" y="8685213"/>
-            <a:ext cx="2971800" cy="457200"/>
-          </a:xfrm>
-          <a:prstGeom prst="rect">
-            <a:avLst/>
-          </a:prstGeom>
-        </p:spPr>
-        <p:txBody>
-          <a:bodyPr vert="horz" lIns="91440" tIns="45720" rIns="91440" bIns="45720" rtlCol="0" anchor="b"/>
-          <a:lstStyle>
-            <a:lvl1pPr algn="r">
-              <a:defRPr sz="1200"/>
-            </a:lvl1pPr>
-          </a:lstStyle>
-          <a:p>
-            <a:fld id="{BB5E49A5-4136-284D-997B-48E1D791AD67}" type="slidenum">
-              <a:rPr lang="en-US" smtClean="0"/>
-              <a:t>‹#›</a:t>
-            </a:fld>
-            <a:endParaRPr lang="en-US"/>
-          </a:p>
-        </p:txBody>
-      </p:sp>
-    </p:spTree>
-    <p:extLst>
-      <p:ext uri="{BB962C8B-B14F-4D97-AF65-F5344CB8AC3E}">
-        <p14:creationId xmlns:p14="http://schemas.microsoft.com/office/powerpoint/2010/main" val="2623252185"/>
-      </p:ext>
-    </p:extLst>
-  </p:cSld>
-  <p:clrMap bg1="lt1" tx1="dk1" bg2="lt2" tx2="dk2" accent1="accent1" accent2="accent2" accent3="accent3" accent4="accent4" accent5="accent5" accent6="accent6" hlink="hlink" folHlink="folHlink"/>
-  <p:notesStyle>
-    <a:lvl1pPr marL="0" algn="l" defTabSz="457200" rtl="0" eaLnBrk="1" latinLnBrk="0" hangingPunct="1">
-      <a:defRPr sz="1200" kern="1200">
-        <a:solidFill>
-          <a:schemeClr val="tx1"/>
-        </a:solidFill>
-        <a:latin typeface="+mn-lt"/>
-        <a:ea typeface="+mn-ea"/>
-        <a:cs typeface="+mn-cs"/>
-      </a:defRPr>
-    </a:lvl1pPr>
-    <a:lvl2pPr marL="457200" algn="l" defTabSz="457200" rtl="0" eaLnBrk="1" latinLnBrk="0" hangingPunct="1">
-      <a:defRPr sz="1200" kern="1200">
-        <a:solidFill>
-          <a:schemeClr val="tx1"/>
-        </a:solidFill>
-        <a:latin typeface="+mn-lt"/>
-        <a:ea typeface="+mn-ea"/>
-        <a:cs typeface="+mn-cs"/>
-      </a:defRPr>
-    </a:lvl2pPr>
-    <a:lvl3pPr marL="914400" algn="l" defTabSz="457200" rtl="0" eaLnBrk="1" latinLnBrk="0" hangingPunct="1">
-      <a:defRPr sz="1200" kern="1200">
-        <a:solidFill>
-          <a:schemeClr val="tx1"/>
-        </a:solidFill>
-        <a:latin typeface="+mn-lt"/>
-        <a:ea typeface="+mn-ea"/>
-        <a:cs typeface="+mn-cs"/>
-      </a:defRPr>
-    </a:lvl3pPr>
-    <a:lvl4pPr marL="1371600" algn="l" defTabSz="457200" rtl="0" eaLnBrk="1" latinLnBrk="0" hangingPunct="1">
-      <a:defRPr sz="1200" kern="1200">
-        <a:solidFill>
-          <a:schemeClr val="tx1"/>
-        </a:solidFill>
-        <a:latin typeface="+mn-lt"/>
-        <a:ea typeface="+mn-ea"/>
-        <a:cs typeface="+mn-cs"/>
-      </a:defRPr>
-    </a:lvl4pPr>
-    <a:lvl5pPr marL="1828800" algn="l" defTabSz="457200" rtl="0" eaLnBrk="1" latinLnBrk="0" hangingPunct="1">
-      <a:defRPr sz="1200" kern="1200">
-        <a:solidFill>
-          <a:schemeClr val="tx1"/>
-        </a:solidFill>
-        <a:latin typeface="+mn-lt"/>
-        <a:ea typeface="+mn-ea"/>
-        <a:cs typeface="+mn-cs"/>
-      </a:defRPr>
-    </a:lvl5pPr>
-    <a:lvl6pPr marL="2286000" algn="l" defTabSz="457200" rtl="0" eaLnBrk="1" latinLnBrk="0" hangingPunct="1">
-      <a:defRPr sz="1200" kern="1200">
-        <a:solidFill>
-          <a:schemeClr val="tx1"/>
-        </a:solidFill>
-        <a:latin typeface="+mn-lt"/>
-        <a:ea typeface="+mn-ea"/>
-        <a:cs typeface="+mn-cs"/>
-      </a:defRPr>
-    </a:lvl6pPr>
-    <a:lvl7pPr marL="2743200" algn="l" defTabSz="457200" rtl="0" eaLnBrk="1" latinLnBrk="0" hangingPunct="1">
-      <a:defRPr sz="1200" kern="1200">
-        <a:solidFill>
-          <a:schemeClr val="tx1"/>
-        </a:solidFill>
-        <a:latin typeface="+mn-lt"/>
-        <a:ea typeface="+mn-ea"/>
-        <a:cs typeface="+mn-cs"/>
-      </a:defRPr>
-    </a:lvl7pPr>
-    <a:lvl8pPr marL="3200400" algn="l" defTabSz="457200" rtl="0" eaLnBrk="1" latinLnBrk="0" hangingPunct="1">
-      <a:defRPr sz="1200" kern="1200">
-        <a:solidFill>
-          <a:schemeClr val="tx1"/>
-        </a:solidFill>
-        <a:latin typeface="+mn-lt"/>
-        <a:ea typeface="+mn-ea"/>
-        <a:cs typeface="+mn-cs"/>
-      </a:defRPr>
-    </a:lvl8pPr>
-    <a:lvl9pPr marL="3657600" algn="l" defTabSz="457200" rtl="0" eaLnBrk="1" latinLnBrk="0" hangingPunct="1">
-      <a:defRPr sz="1200" kern="1200">
-        <a:solidFill>
-          <a:schemeClr val="tx1"/>
-        </a:solidFill>
-        <a:latin typeface="+mn-lt"/>
-        <a:ea typeface="+mn-ea"/>
-        <a:cs typeface="+mn-cs"/>
-      </a:defRPr>
-    </a:lvl9pPr>
-  </p:notesStyle>
-</p:notesMaster>
-</file>
-
-<file path=ppt/notesSlides/notesSlide1.xml><?xml version="1.0" encoding="utf-8"?>
-<p:notes xmlns:a="http://schemas.openxmlformats.org/drawingml/2006/main" xmlns:p="http://schemas.openxmlformats.org/presentationml/2006/main" xmlns:r="http://schemas.openxmlformats.org/officeDocument/2006/relationships">
-  <p:cSld>
-    <p:spTree>
-      <p:nvGrpSpPr>
-        <p:cNvPr id="1" name=""/>
-        <p:cNvGrpSpPr/>
-        <p:nvPr/>
-      </p:nvGrpSpPr>
-      <p:grpSpPr>
-        <a:xfrm>
-          <a:off x="0" y="0"/>
-          <a:ext cx="0" cy="0"/>
-          <a:chOff x="0" y="0"/>
-          <a:chExt cx="0" cy="0"/>
-        </a:xfrm>
-      </p:grpSpPr>
-      <p:sp>
-        <p:nvSpPr>
-          <p:cNvPr id="2" name="Slide Image Placeholder 1"/>
-          <p:cNvSpPr>
-            <a:spLocks noGrp="1"/>
-          </p:cNvSpPr>
-          <p:nvPr>
-            <p:ph type="sldImg" idx="2"/>
-          </p:nvPr>
-        </p:nvSpPr>
-        <p:spPr/>
-      </p:sp>
-      <p:sp>
-        <p:nvSpPr>
-          <p:cNvPr id="3" name="Notes Placeholder 2"/>
-          <p:cNvSpPr>
-            <a:spLocks noGrp="1"/>
-          </p:cNvSpPr>
-          <p:nvPr>
-            <p:ph type="body" idx="3" sz="quarter"/>
-          </p:nvPr>
-        </p:nvSpPr>
-        <p:spPr/>
-        <p:txBody>
-          <a:bodyPr/>
-          <a:lstStyle/>
-          <a:p>
-            <a:r>
-              <a:t>TR: Merhaba, biz Kumbara ekibiyiz: Ahmed Murshed, Kutay Sarı, Ben Luelo; üç mühendis, hepsi Stellar üzerinde üretiyor. Kumbara, lirayla maaş alanlar için dolar birikimi: havale ile yükle, USDC olarak kasada dursun, istediğinde liraya çek. Tek anahtar bir passkey. Her şey Stellar test ağında.</a:t>
-            </a:r>
-          </a:p>
-          <a:p/>
-          <a:p>
-            <a:r>
-              <a:t>EN: Hi, we are the Kumbara team: Ahmed Murshed, Kutay Sarı and Ben Luelo, three engineers, all shipping on Stellar. Kumbara is dollar savings for people paid in lira: bank transfer in, USDC in a vault, lira back out. A passkey is the only key. Everything here runs on Stellar testnet.</a:t>
-            </a:r>
-          </a:p>
-        </p:txBody>
-      </p:sp>
-      <p:sp>
-        <p:nvSpPr>
-          <p:cNvPr id="4" name="Slide Number Placeholder 3"/>
-          <p:cNvSpPr>
-            <a:spLocks noGrp="1"/>
-          </p:cNvSpPr>
-          <p:nvPr>
-            <p:ph type="sldNum" idx="5" sz="quarter"/>
-          </p:nvPr>
-        </p:nvSpPr>
-        <p:spPr/>
-      </p:sp>
-    </p:spTree>
-  </p:cSld>
-  <p:clrMapOvr>
-    <a:masterClrMapping/>
-  </p:clrMapOvr>
-</p:notes>
-</file>
-
-<file path=ppt/notesSlides/notesSlide2.xml><?xml version="1.0" encoding="utf-8"?>
-<p:notes xmlns:a="http://schemas.openxmlformats.org/drawingml/2006/main" xmlns:p="http://schemas.openxmlformats.org/presentationml/2006/main" xmlns:r="http://schemas.openxmlformats.org/officeDocument/2006/relationships">
-  <p:cSld>
-    <p:spTree>
-      <p:nvGrpSpPr>
-        <p:cNvPr id="1" name=""/>
-        <p:cNvGrpSpPr/>
-        <p:nvPr/>
-      </p:nvGrpSpPr>
-      <p:grpSpPr>
-        <a:xfrm>
-          <a:off x="0" y="0"/>
-          <a:ext cx="0" cy="0"/>
-          <a:chOff x="0" y="0"/>
-          <a:chExt cx="0" cy="0"/>
-        </a:xfrm>
-      </p:grpSpPr>
-      <p:sp>
-        <p:nvSpPr>
-          <p:cNvPr id="2" name="Slide Image Placeholder 1"/>
-          <p:cNvSpPr>
-            <a:spLocks noGrp="1"/>
-          </p:cNvSpPr>
-          <p:nvPr>
-            <p:ph type="sldImg" idx="2"/>
-          </p:nvPr>
-        </p:nvSpPr>
-        <p:spPr/>
-      </p:sp>
-      <p:sp>
-        <p:nvSpPr>
-          <p:cNvPr id="3" name="Notes Placeholder 2"/>
-          <p:cNvSpPr>
-            <a:spLocks noGrp="1"/>
-          </p:cNvSpPr>
-          <p:nvPr>
-            <p:ph type="body" idx="3" sz="quarter"/>
-          </p:nvPr>
-        </p:nvSpPr>
-        <p:spPr/>
-        <p:txBody>
-          <a:bodyPr/>
-          <a:lstStyle/>
-          <a:p>
-            <a:r>
-              <a:t>TR: Merkez bankası kuru: 2019 sonunda bir dolar 5,94 lira, bugün 48,23. Sekiz kat. Enflasyon yüzde 31,5. 2019'da bankada bırakılan yüz bin lira bugün iki bin dolar; dolar olarak tutulsaydı on yedi bin. Dolar yolu ise borsa uygulaması, tohum kelime, gaz için XLM.</a:t>
-            </a:r>
-          </a:p>
-          <a:p/>
-          <a:p>
-            <a:r>
-              <a:t>EN: Central bank rate: a dollar was 5.94 lira at the end of 2019, 48.23 today. Eight times. Inflation is 31.5 percent. A hundred thousand lira left in the bank since 2019 is two thousand dollars now; kept as dollars, seventeen thousand. The dollar route means an exchange app, a seed phrase, XLM for gas.</a:t>
-            </a:r>
-          </a:p>
-        </p:txBody>
-      </p:sp>
-      <p:sp>
-        <p:nvSpPr>
-          <p:cNvPr id="4" name="Slide Number Placeholder 3"/>
-          <p:cNvSpPr>
-            <a:spLocks noGrp="1"/>
-          </p:cNvSpPr>
-          <p:nvPr>
-            <p:ph type="sldNum" idx="5" sz="quarter"/>
-          </p:nvPr>
-        </p:nvSpPr>
-        <p:spPr/>
-      </p:sp>
-    </p:spTree>
-  </p:cSld>
-  <p:clrMapOvr>
-    <a:masterClrMapping/>
-  </p:clrMapOvr>
-</p:notes>
-</file>
-
-<file path=ppt/notesSlides/notesSlide3.xml><?xml version="1.0" encoding="utf-8"?>
-<p:notes xmlns:a="http://schemas.openxmlformats.org/drawingml/2006/main" xmlns:p="http://schemas.openxmlformats.org/presentationml/2006/main" xmlns:r="http://schemas.openxmlformats.org/officeDocument/2006/relationships">
-  <p:cSld>
-    <p:spTree>
-      <p:nvGrpSpPr>
-        <p:cNvPr id="1" name=""/>
-        <p:cNvGrpSpPr/>
-        <p:nvPr/>
-      </p:nvGrpSpPr>
-      <p:grpSpPr>
-        <a:xfrm>
-          <a:off x="0" y="0"/>
-          <a:ext cx="0" cy="0"/>
-          <a:chOff x="0" y="0"/>
-          <a:chExt cx="0" cy="0"/>
-        </a:xfrm>
-      </p:grpSpPr>
-      <p:sp>
-        <p:nvSpPr>
-          <p:cNvPr id="2" name="Slide Image Placeholder 1"/>
-          <p:cNvSpPr>
-            <a:spLocks noGrp="1"/>
-          </p:cNvSpPr>
-          <p:nvPr>
-            <p:ph type="sldImg" idx="2"/>
-          </p:nvPr>
-        </p:nvSpPr>
-        <p:spPr/>
-      </p:sp>
-      <p:sp>
-        <p:nvSpPr>
-          <p:cNvPr id="3" name="Notes Placeholder 2"/>
-          <p:cNvSpPr>
-            <a:spLocks noGrp="1"/>
-          </p:cNvSpPr>
-          <p:nvPr>
-            <p:ph type="body" idx="3" sz="quarter"/>
-          </p:nvPr>
-        </p:nvSpPr>
-        <p:spPr/>
-        <p:txBody>
-          <a:bodyPr/>
-          <a:lstStyle/>
-          <a:p>
-            <a:r>
-              <a:t>TR: Dört ekran. Bir dokunuş, passkey anahtarı üretir. Lirayı her zamanki gibi IBAN'a gönderirsin. USDC olarak DeFindex kasasında durur; anahtar sende. İstediğinde kendi IBAN'ına lira olarak geri döner.</a:t>
-            </a:r>
-          </a:p>
-          <a:p/>
-          <a:p>
-            <a:r>
-              <a:t>EN: Four screens. One tap, a passkey makes the key. You send lira to an IBAN as you always do. It sits as USDC in a DeFindex vault; you hold the key. Lira comes back to your own IBAN whenever you want.</a:t>
-            </a:r>
-          </a:p>
-        </p:txBody>
-      </p:sp>
-      <p:sp>
-        <p:nvSpPr>
-          <p:cNvPr id="4" name="Slide Number Placeholder 3"/>
-          <p:cNvSpPr>
-            <a:spLocks noGrp="1"/>
-          </p:cNvSpPr>
-          <p:nvPr>
-            <p:ph type="sldNum" idx="5" sz="quarter"/>
-          </p:nvPr>
-        </p:nvSpPr>
-        <p:spPr/>
-      </p:sp>
-    </p:spTree>
-  </p:cSld>
-  <p:clrMapOvr>
-    <a:masterClrMapping/>
-  </p:clrMapOvr>
-</p:notes>
-</file>
-
-<file path=ppt/notesSlides/notesSlide4.xml><?xml version="1.0" encoding="utf-8"?>
-<p:notes xmlns:a="http://schemas.openxmlformats.org/drawingml/2006/main" xmlns:p="http://schemas.openxmlformats.org/presentationml/2006/main" xmlns:r="http://schemas.openxmlformats.org/officeDocument/2006/relationships">
-  <p:cSld>
-    <p:spTree>
-      <p:nvGrpSpPr>
-        <p:cNvPr id="1" name=""/>
-        <p:cNvGrpSpPr/>
-        <p:nvPr/>
-      </p:nvGrpSpPr>
-      <p:grpSpPr>
-        <a:xfrm>
-          <a:off x="0" y="0"/>
-          <a:ext cx="0" cy="0"/>
-          <a:chOff x="0" y="0"/>
-          <a:chExt cx="0" cy="0"/>
-        </a:xfrm>
-      </p:grpSpPr>
-      <p:sp>
-        <p:nvSpPr>
-          <p:cNvPr id="2" name="Slide Image Placeholder 1"/>
-          <p:cNvSpPr>
-            <a:spLocks noGrp="1"/>
-          </p:cNvSpPr>
-          <p:nvPr>
-            <p:ph type="sldImg" idx="2"/>
-          </p:nvPr>
-        </p:nvSpPr>
-        <p:spPr/>
-      </p:sp>
-      <p:sp>
-        <p:nvSpPr>
-          <p:cNvPr id="3" name="Notes Placeholder 2"/>
-          <p:cNvSpPr>
-            <a:spLocks noGrp="1"/>
-          </p:cNvSpPr>
-          <p:nvPr>
-            <p:ph type="body" idx="3" sz="quarter"/>
-          </p:nvPr>
-        </p:nvSpPr>
-        <p:spPr/>
-        <p:txBody>
-          <a:bodyPr/>
-          <a:lstStyle/>
-          <a:p>
-            <a:r>
-              <a:t>TR: Şimdi deneyin: kodu okutun, Kumbaranı aç'a dokunun, Face ID ya da Touch ID. Hesabınız açıldı. Yükle deyin, yüz yazın; bankayı ben oynatıyorum, bir dakikaya USDC kasada. Çek deyin, lira IBAN'a döner. Kurulum yok, kelime yok, XLM yok. Test ağı, gerçek para değil. Sayaç arkamda.</a:t>
-            </a:r>
-          </a:p>
-          <a:p/>
-          <a:p>
-            <a:r>
-              <a:t>EN: Try it now: scan, tap Kumbaranı aç, Face ID or Touch ID. Your account exists. Tap Yükle, enter one hundred; I play the bank, and in about a minute the USDC is in the vault. Tap Çek and the lira comes back to the IBAN. No install, no words, no XLM. Testnet, not real money. The counter is behind me.</a:t>
-            </a:r>
-          </a:p>
-        </p:txBody>
-      </p:sp>
-      <p:sp>
-        <p:nvSpPr>
-          <p:cNvPr id="4" name="Slide Number Placeholder 3"/>
-          <p:cNvSpPr>
-            <a:spLocks noGrp="1"/>
-          </p:cNvSpPr>
-          <p:nvPr>
-            <p:ph type="sldNum" idx="5" sz="quarter"/>
-          </p:nvPr>
-        </p:nvSpPr>
-        <p:spPr/>
-      </p:sp>
-    </p:spTree>
-  </p:cSld>
-  <p:clrMapOvr>
-    <a:masterClrMapping/>
-  </p:clrMapOvr>
-</p:notes>
-</file>
-
-<file path=ppt/notesSlides/notesSlide5.xml><?xml version="1.0" encoding="utf-8"?>
-<p:notes xmlns:a="http://schemas.openxmlformats.org/drawingml/2006/main" xmlns:p="http://schemas.openxmlformats.org/presentationml/2006/main" xmlns:r="http://schemas.openxmlformats.org/officeDocument/2006/relationships">
-  <p:cSld>
-    <p:spTree>
-      <p:nvGrpSpPr>
-        <p:cNvPr id="1" name=""/>
-        <p:cNvGrpSpPr/>
-        <p:nvPr/>
-      </p:nvGrpSpPr>
-      <p:grpSpPr>
-        <a:xfrm>
-          <a:off x="0" y="0"/>
-          <a:ext cx="0" cy="0"/>
-          <a:chOff x="0" y="0"/>
-          <a:chExt cx="0" cy="0"/>
-        </a:xfrm>
-      </p:grpSpPr>
-      <p:sp>
-        <p:nvSpPr>
-          <p:cNvPr id="2" name="Slide Image Placeholder 1"/>
-          <p:cNvSpPr>
-            <a:spLocks noGrp="1"/>
-          </p:cNvSpPr>
-          <p:nvPr>
-            <p:ph type="sldImg" idx="2"/>
-          </p:nvPr>
-        </p:nvSpPr>
-        <p:spPr/>
-      </p:sp>
-      <p:sp>
-        <p:nvSpPr>
-          <p:cNvPr id="3" name="Notes Placeholder 2"/>
-          <p:cNvSpPr>
-            <a:spLocks noGrp="1"/>
-          </p:cNvSpPr>
-          <p:nvPr>
-            <p:ph type="body" idx="3" sz="quarter"/>
-          </p:nvPr>
-        </p:nvSpPr>
-        <p:spPr/>
-        <p:txBody>
-          <a:bodyPr/>
-          <a:lstStyle/>
-          <a:p>
-            <a:r>
-              <a:t>TR: Paranızı kim tutuyor? Bankada banka, borsada borsa; tohum kelimeli cüzdanda ve Kumbara'da siz. Fark ödevde: cüzdan on iki kelime, gaz için XLM ve kurulum ister; lira giriş çıkışı anchor desteğine bağlıdır. Kumbara'da passkey imzalar, relay ücreti öder, lisanslı anchor lirayı taşır; kurulacak bir şey yok.</a:t>
-            </a:r>
-          </a:p>
-          <a:p/>
-          <a:p>
-            <a:r>
-              <a:t>EN: Who holds your money? At the bank, the bank; at the exchange, the exchange; with a seed-phrase wallet and with Kumbara, you. The difference is the homework: a wallet demands twelve words, XLM for gas and an install, and lira in and out depends on its anchor support. With Kumbara a passkey signs, a relay pays the fees, a licensed anchor moves the lira; nothing to install.</a:t>
-            </a:r>
-          </a:p>
-        </p:txBody>
-      </p:sp>
-      <p:sp>
-        <p:nvSpPr>
-          <p:cNvPr id="4" name="Slide Number Placeholder 3"/>
-          <p:cNvSpPr>
-            <a:spLocks noGrp="1"/>
-          </p:cNvSpPr>
-          <p:nvPr>
-            <p:ph type="sldNum" idx="5" sz="quarter"/>
-          </p:nvPr>
-        </p:nvSpPr>
-        <p:spPr/>
-      </p:sp>
-    </p:spTree>
-  </p:cSld>
-  <p:clrMapOvr>
-    <a:masterClrMapping/>
-  </p:clrMapOvr>
-</p:notes>
-</file>
-
-<file path=ppt/notesSlides/notesSlide6.xml><?xml version="1.0" encoding="utf-8"?>
-<p:notes xmlns:a="http://schemas.openxmlformats.org/drawingml/2006/main" xmlns:p="http://schemas.openxmlformats.org/presentationml/2006/main" xmlns:r="http://schemas.openxmlformats.org/officeDocument/2006/relationships">
-  <p:cSld>
-    <p:spTree>
-      <p:nvGrpSpPr>
-        <p:cNvPr id="1" name=""/>
-        <p:cNvGrpSpPr/>
-        <p:nvPr/>
-      </p:nvGrpSpPr>
-      <p:grpSpPr>
-        <a:xfrm>
-          <a:off x="0" y="0"/>
-          <a:ext cx="0" cy="0"/>
-          <a:chOff x="0" y="0"/>
-          <a:chExt cx="0" cy="0"/>
-        </a:xfrm>
-      </p:grpSpPr>
-      <p:sp>
-        <p:nvSpPr>
-          <p:cNvPr id="2" name="Slide Image Placeholder 1"/>
-          <p:cNvSpPr>
-            <a:spLocks noGrp="1"/>
-          </p:cNvSpPr>
-          <p:nvPr>
-            <p:ph type="sldImg" idx="2"/>
-          </p:nvPr>
-        </p:nvSpPr>
-        <p:spPr/>
-      </p:sp>
-      <p:sp>
-        <p:nvSpPr>
-          <p:cNvPr id="3" name="Notes Placeholder 2"/>
-          <p:cNvSpPr>
-            <a:spLocks noGrp="1"/>
-          </p:cNvSpPr>
-          <p:nvPr>
-            <p:ph type="body" idx="3" sz="quarter"/>
-          </p:nvPr>
-        </p:nvSpPr>
-        <p:spPr/>
-        <p:txBody>
-          <a:bodyPr/>
-          <a:lstStyle/>
-          <a:p>
-            <a:r>
-              <a:t>TR: Beş hamle: passkey akıllı hesabı açar, limit zincire yazılır, anchor IBAN verir, geçici hesap USDC'yi iletir, bir onayla kasa. Köprü: anchor yalnızca normal bir Stellar hesabına ödeyebilir. Para gelmeden önce yalnızca iki işlemi imzalanmış geçici bir hesap yaratırız: ilet, sonra kapan. Biz dahil kimse yönünü değiştiremez. Emanet yok, bize güven gerekmiyor.</a:t>
-            </a:r>
-          </a:p>
-          <a:p/>
-          <a:p>
-            <a:r>
-              <a:t>EN: Five moves: a passkey opens the smart account, the limit is written on-chain, the anchor issues an IBAN, a temporary account forwards the USDC, one approval into the vault. The bridge: the anchor can only pay a normal Stellar account. We create a temporary account whose only two transactions are signed before any money arrives: forward, then close. Nobody, including us, can redirect it. No custody, no trust in us.</a:t>
-            </a:r>
-          </a:p>
-        </p:txBody>
-      </p:sp>
-      <p:sp>
-        <p:nvSpPr>
-          <p:cNvPr id="4" name="Slide Number Placeholder 3"/>
-          <p:cNvSpPr>
-            <a:spLocks noGrp="1"/>
-          </p:cNvSpPr>
-          <p:nvPr>
-            <p:ph type="sldNum" idx="5" sz="quarter"/>
-          </p:nvPr>
-        </p:nvSpPr>
-        <p:spPr/>
-      </p:sp>
-    </p:spTree>
-  </p:cSld>
-  <p:clrMapOvr>
-    <a:masterClrMapping/>
-  </p:clrMapOvr>
-</p:notes>
-</file>
-
-<file path=ppt/notesSlides/notesSlide7.xml><?xml version="1.0" encoding="utf-8"?>
-<p:notes xmlns:a="http://schemas.openxmlformats.org/drawingml/2006/main" xmlns:p="http://schemas.openxmlformats.org/presentationml/2006/main" xmlns:r="http://schemas.openxmlformats.org/officeDocument/2006/relationships">
-  <p:cSld>
-    <p:spTree>
-      <p:nvGrpSpPr>
-        <p:cNvPr id="1" name=""/>
-        <p:cNvGrpSpPr/>
-        <p:nvPr/>
-      </p:nvGrpSpPr>
-      <p:grpSpPr>
-        <a:xfrm>
-          <a:off x="0" y="0"/>
-          <a:ext cx="0" cy="0"/>
-          <a:chOff x="0" y="0"/>
-          <a:chExt cx="0" cy="0"/>
-        </a:xfrm>
-      </p:grpSpPr>
-      <p:sp>
-        <p:nvSpPr>
-          <p:cNvPr id="2" name="Slide Image Placeholder 1"/>
-          <p:cNvSpPr>
-            <a:spLocks noGrp="1"/>
-          </p:cNvSpPr>
-          <p:nvPr>
-            <p:ph type="sldImg" idx="2"/>
-          </p:nvPr>
-        </p:nvSpPr>
-        <p:spPr/>
-      </p:sp>
-      <p:sp>
-        <p:nvSpPr>
-          <p:cNvPr id="3" name="Notes Placeholder 2"/>
-          <p:cNvSpPr>
-            <a:spLocks noGrp="1"/>
-          </p:cNvSpPr>
-          <p:nvPr>
-            <p:ph type="body" idx="3" sz="quarter"/>
-          </p:nvPr>
-        </p:nvSpPr>
-        <p:spPr/>
-        <p:txBody>
-          <a:bodyPr/>
-          <a:lstStyle/>
-          <a:p>
-            <a:r>
-              <a:t>TR: Aynı uygulama, sıradaki anchor. Türkiye bugün sandbox anchor'la; Arjantin ve Bolivya Koywe ile listede, API bir iki hafta. Ana ağdan önce anchor'ı seçeriz: lisanslı, kendi banka hesabına ödeyen, emanet almayan uygulamaya yazılı teyit veren. TRY anchor'ı uyarsa Türkiye; yoksa Koywe ile Arjantin. İki durumda da aynı uygulama.</a:t>
-            </a:r>
-          </a:p>
-          <a:p/>
-          <a:p>
-            <a:r>
-              <a:t>EN: Same app, next anchor. Türkiye runs on a sandbox anchor today; Argentina and Bolivia are on the list through Koywe, API in one to two weeks. Before mainnet we pick the anchor: licensed, pays your own bank account, confirms in writing that a non-custodial app can integrate. Türkiye if a TRY anchor qualifies; otherwise Argentina on Koywe. Same app either way.</a:t>
-            </a:r>
-          </a:p>
-        </p:txBody>
-      </p:sp>
-      <p:sp>
-        <p:nvSpPr>
-          <p:cNvPr id="4" name="Slide Number Placeholder 3"/>
-          <p:cNvSpPr>
-            <a:spLocks noGrp="1"/>
-          </p:cNvSpPr>
-          <p:nvPr>
-            <p:ph type="sldNum" idx="5" sz="quarter"/>
-          </p:nvPr>
-        </p:nvSpPr>
-        <p:spPr/>
-      </p:sp>
-    </p:spTree>
-  </p:cSld>
-  <p:clrMapOvr>
-    <a:masterClrMapping/>
-  </p:clrMapOvr>
-</p:notes>
-</file>
-
-<file path=ppt/notesSlides/notesSlide8.xml><?xml version="1.0" encoding="utf-8"?>
-<p:notes xmlns:a="http://schemas.openxmlformats.org/drawingml/2006/main" xmlns:p="http://schemas.openxmlformats.org/presentationml/2006/main" xmlns:r="http://schemas.openxmlformats.org/officeDocument/2006/relationships">
-  <p:cSld>
-    <p:spTree>
-      <p:nvGrpSpPr>
-        <p:cNvPr id="1" name=""/>
-        <p:cNvGrpSpPr/>
-        <p:nvPr/>
-      </p:nvGrpSpPr>
-      <p:grpSpPr>
-        <a:xfrm>
-          <a:off x="0" y="0"/>
-          <a:ext cx="0" cy="0"/>
-          <a:chOff x="0" y="0"/>
-          <a:chExt cx="0" cy="0"/>
-        </a:xfrm>
-      </p:grpSpPr>
-      <p:sp>
-        <p:nvSpPr>
-          <p:cNvPr id="2" name="Slide Image Placeholder 1"/>
-          <p:cNvSpPr>
-            <a:spLocks noGrp="1"/>
-          </p:cNvSpPr>
-          <p:nvPr>
-            <p:ph type="sldImg" idx="2"/>
-          </p:nvPr>
-        </p:nvSpPr>
-        <p:spPr/>
-      </p:sp>
-      <p:sp>
-        <p:nvSpPr>
-          <p:cNvPr id="3" name="Notes Placeholder 2"/>
-          <p:cNvSpPr>
-            <a:spLocks noGrp="1"/>
-          </p:cNvSpPr>
-          <p:nvPr>
-            <p:ph type="body" idx="3" sz="quarter"/>
-          </p:nvPr>
-        </p:nvSpPr>
-        <p:spPr/>
-        <p:txBody>
-          <a:bodyPr/>
-          <a:lstStyle/>
-          <a:p>
-            <a:r>
-              <a:t>TR: Kullanıcılar ve işlemler, hepsi zincirde: üç kumbara açıldı, iki yükleme, çekim yok, kasada 208 USDC; test hesapları sayılmadı. Her sayının bağlantısı ekranda. 19–20 Eylül'de bunlar stant sayıları olacak. Sırada: Sembol Cloud v0 ana ağda, anchor görüşmeleri, etkinlikten sonra SCF Integration Track.</a:t>
-            </a:r>
-          </a:p>
-          <a:p/>
-          <a:p>
-            <a:r>
-              <a:t>EN: Users and transactions, all on chain: three kumbaras opened, two deposits, no withdrawals, 208 USDC in the vault; test accounts excluded. Every number links. On 19–20 September these become the booth numbers. Next: Sembol Cloud v0 on mainnet, anchor conversations, the SCF Integration Track after the event.</a:t>
-            </a:r>
-          </a:p>
-        </p:txBody>
-      </p:sp>
-      <p:sp>
-        <p:nvSpPr>
-          <p:cNvPr id="4" name="Slide Number Placeholder 3"/>
-          <p:cNvSpPr>
-            <a:spLocks noGrp="1"/>
-          </p:cNvSpPr>
-          <p:nvPr>
-            <p:ph type="sldNum" idx="5" sz="quarter"/>
-          </p:nvPr>
-        </p:nvSpPr>
-        <p:spPr/>
-      </p:sp>
-    </p:spTree>
-  </p:cSld>
-  <p:clrMapOvr>
-    <a:masterClrMapping/>
-  </p:clrMapOvr>
-</p:notes>
 </file>
 
 <file path=ppt/slideLayouts/slideLayout1.xml><?xml version="1.0" encoding="utf-8"?>
@@ -4697,324 +3739,4 @@
   </a:objectDefaults>
   <a:extraClrSchemeLst/>
 </a:theme>
-</file>
-
-<file path=ppt/theme/theme2.xml><?xml version="1.0" encoding="utf-8"?>
-<a:theme xmlns:a="http://schemas.openxmlformats.org/drawingml/2006/main" name="Office Theme">
-  <a:themeElements>
-    <a:clrScheme name="Office">
-      <a:dk1>
-        <a:sysClr val="windowText" lastClr="000000"/>
-      </a:dk1>
-      <a:lt1>
-        <a:sysClr val="window" lastClr="FFFFFF"/>
-      </a:lt1>
-      <a:dk2>
-        <a:srgbClr val="1F497D"/>
-      </a:dk2>
-      <a:lt2>
-        <a:srgbClr val="EEECE1"/>
-      </a:lt2>
-      <a:accent1>
-        <a:srgbClr val="4F81BD"/>
-      </a:accent1>
-      <a:accent2>
-        <a:srgbClr val="C0504D"/>
-      </a:accent2>
-      <a:accent3>
-        <a:srgbClr val="9BBB59"/>
-      </a:accent3>
-      <a:accent4>
-        <a:srgbClr val="8064A2"/>
-      </a:accent4>
-      <a:accent5>
-        <a:srgbClr val="4BACC6"/>
-      </a:accent5>
-      <a:accent6>
-        <a:srgbClr val="F79646"/>
-      </a:accent6>
-      <a:hlink>
-        <a:srgbClr val="0000FF"/>
-      </a:hlink>
-      <a:folHlink>
-        <a:srgbClr val="800080"/>
-      </a:folHlink>
-    </a:clrScheme>
-    <a:fontScheme name="Office">
-      <a:majorFont>
-        <a:latin typeface="Calibri"/>
-        <a:ea typeface=""/>
-        <a:cs typeface=""/>
-        <a:font script="Jpan" typeface="ＭＳ Ｐゴシック"/>
-        <a:font script="Hang" typeface="맑은 고딕"/>
-        <a:font script="Hans" typeface="宋体"/>
-        <a:font script="Hant" typeface="新細明體"/>
-        <a:font script="Arab" typeface="Times New Roman"/>
-        <a:font script="Hebr" typeface="Times New Roman"/>
-        <a:font script="Thai" typeface="Angsana New"/>
-        <a:font script="Ethi" typeface="Nyala"/>
-        <a:font script="Beng" typeface="Vrinda"/>
-        <a:font script="Gujr" typeface="Shruti"/>
-        <a:font script="Khmr" typeface="MoolBoran"/>
-        <a:font script="Knda" typeface="Tunga"/>
-        <a:font script="Guru" typeface="Raavi"/>
-        <a:font script="Cans" typeface="Euphemia"/>
-        <a:font script="Cher" typeface="Plantagenet Cherokee"/>
-        <a:font script="Yiii" typeface="Microsoft Yi Baiti"/>
-        <a:font script="Tibt" typeface="Microsoft Himalaya"/>
-        <a:font script="Thaa" typeface="MV Boli"/>
-        <a:font script="Deva" typeface="Mangal"/>
-        <a:font script="Telu" typeface="Gautami"/>
-        <a:font script="Taml" typeface="Latha"/>
-        <a:font script="Syrc" typeface="Estrangelo Edessa"/>
-        <a:font script="Orya" typeface="Kalinga"/>
-        <a:font script="Mlym" typeface="Kartika"/>
-        <a:font script="Laoo" typeface="DokChampa"/>
-        <a:font script="Sinh" typeface="Iskoola Pota"/>
-        <a:font script="Mong" typeface="Mongolian Baiti"/>
-        <a:font script="Viet" typeface="Times New Roman"/>
-        <a:font script="Uigh" typeface="Microsoft Uighur"/>
-        <a:font script="Geor" typeface="Sylfaen"/>
-      </a:majorFont>
-      <a:minorFont>
-        <a:latin typeface="Calibri"/>
-        <a:ea typeface=""/>
-        <a:cs typeface=""/>
-        <a:font script="Jpan" typeface="ＭＳ Ｐゴシック"/>
-        <a:font script="Hang" typeface="맑은 고딕"/>
-        <a:font script="Hans" typeface="宋体"/>
-        <a:font script="Hant" typeface="新細明體"/>
-        <a:font script="Arab" typeface="Arial"/>
-        <a:font script="Hebr" typeface="Arial"/>
-        <a:font script="Thai" typeface="Cordia New"/>
-        <a:font script="Ethi" typeface="Nyala"/>
-        <a:font script="Beng" typeface="Vrinda"/>
-        <a:font script="Gujr" typeface="Shruti"/>
-        <a:font script="Khmr" typeface="DaunPenh"/>
-        <a:font script="Knda" typeface="Tunga"/>
-        <a:font script="Guru" typeface="Raavi"/>
-        <a:font script="Cans" typeface="Euphemia"/>
-        <a:font script="Cher" typeface="Plantagenet Cherokee"/>
-        <a:font script="Yiii" typeface="Microsoft Yi Baiti"/>
-        <a:font script="Tibt" typeface="Microsoft Himalaya"/>
-        <a:font script="Thaa" typeface="MV Boli"/>
-        <a:font script="Deva" typeface="Mangal"/>
-        <a:font script="Telu" typeface="Gautami"/>
-        <a:font script="Taml" typeface="Latha"/>
-        <a:font script="Syrc" typeface="Estrangelo Edessa"/>
-        <a:font script="Orya" typeface="Kalinga"/>
-        <a:font script="Mlym" typeface="Kartika"/>
-        <a:font script="Laoo" typeface="DokChampa"/>
-        <a:font script="Sinh" typeface="Iskoola Pota"/>
-        <a:font script="Mong" typeface="Mongolian Baiti"/>
-        <a:font script="Viet" typeface="Arial"/>
-        <a:font script="Uigh" typeface="Microsoft Uighur"/>
-        <a:font script="Geor" typeface="Sylfaen"/>
-      </a:minorFont>
-    </a:fontScheme>
-    <a:fmtScheme name="Office">
-      <a:fillStyleLst>
-        <a:solidFill>
-          <a:schemeClr val="phClr"/>
-        </a:solidFill>
-        <a:gradFill rotWithShape="1">
-          <a:gsLst>
-            <a:gs pos="0">
-              <a:schemeClr val="phClr">
-                <a:tint val="50000"/>
-                <a:satMod val="300000"/>
-              </a:schemeClr>
-            </a:gs>
-            <a:gs pos="35000">
-              <a:schemeClr val="phClr">
-                <a:tint val="37000"/>
-                <a:satMod val="300000"/>
-              </a:schemeClr>
-            </a:gs>
-            <a:gs pos="100000">
-              <a:schemeClr val="phClr">
-                <a:tint val="15000"/>
-                <a:satMod val="350000"/>
-              </a:schemeClr>
-            </a:gs>
-          </a:gsLst>
-          <a:lin ang="16200000" scaled="1"/>
-        </a:gradFill>
-        <a:gradFill rotWithShape="1">
-          <a:gsLst>
-            <a:gs pos="0">
-              <a:schemeClr val="phClr">
-                <a:tint val="100000"/>
-                <a:shade val="100000"/>
-                <a:satMod val="130000"/>
-              </a:schemeClr>
-            </a:gs>
-            <a:gs pos="100000">
-              <a:schemeClr val="phClr">
-                <a:tint val="50000"/>
-                <a:shade val="100000"/>
-                <a:satMod val="350000"/>
-              </a:schemeClr>
-            </a:gs>
-          </a:gsLst>
-          <a:lin ang="16200000" scaled="0"/>
-        </a:gradFill>
-      </a:fillStyleLst>
-      <a:lnStyleLst>
-        <a:ln w="9525" cap="flat" cmpd="sng" algn="ctr">
-          <a:solidFill>
-            <a:schemeClr val="phClr">
-              <a:shade val="95000"/>
-              <a:satMod val="105000"/>
-            </a:schemeClr>
-          </a:solidFill>
-          <a:prstDash val="solid"/>
-        </a:ln>
-        <a:ln w="25400" cap="flat" cmpd="sng" algn="ctr">
-          <a:solidFill>
-            <a:schemeClr val="phClr"/>
-          </a:solidFill>
-          <a:prstDash val="solid"/>
-        </a:ln>
-        <a:ln w="38100" cap="flat" cmpd="sng" algn="ctr">
-          <a:solidFill>
-            <a:schemeClr val="phClr"/>
-          </a:solidFill>
-          <a:prstDash val="solid"/>
-        </a:ln>
-      </a:lnStyleLst>
-      <a:effectStyleLst>
-        <a:effectStyle>
-          <a:effectLst>
-            <a:outerShdw blurRad="40000" dist="20000" dir="5400000" rotWithShape="0">
-              <a:srgbClr val="000000">
-                <a:alpha val="38000"/>
-              </a:srgbClr>
-            </a:outerShdw>
-          </a:effectLst>
-        </a:effectStyle>
-        <a:effectStyle>
-          <a:effectLst>
-            <a:outerShdw blurRad="40000" dist="23000" dir="5400000" rotWithShape="0">
-              <a:srgbClr val="000000">
-                <a:alpha val="35000"/>
-              </a:srgbClr>
-            </a:outerShdw>
-          </a:effectLst>
-        </a:effectStyle>
-        <a:effectStyle>
-          <a:effectLst>
-            <a:outerShdw blurRad="40000" dist="23000" dir="5400000" rotWithShape="0">
-              <a:srgbClr val="000000">
-                <a:alpha val="35000"/>
-              </a:srgbClr>
-            </a:outerShdw>
-          </a:effectLst>
-          <a:scene3d>
-            <a:camera prst="orthographicFront">
-              <a:rot lat="0" lon="0" rev="0"/>
-            </a:camera>
-            <a:lightRig rig="threePt" dir="t">
-              <a:rot lat="0" lon="0" rev="1200000"/>
-            </a:lightRig>
-          </a:scene3d>
-          <a:sp3d>
-            <a:bevelT w="63500" h="25400"/>
-          </a:sp3d>
-        </a:effectStyle>
-      </a:effectStyleLst>
-      <a:bgFillStyleLst>
-        <a:solidFill>
-          <a:schemeClr val="phClr"/>
-        </a:solidFill>
-        <a:gradFill rotWithShape="1">
-          <a:gsLst>
-            <a:gs pos="0">
-              <a:schemeClr val="phClr">
-                <a:tint val="40000"/>
-                <a:satMod val="350000"/>
-              </a:schemeClr>
-            </a:gs>
-            <a:gs pos="40000">
-              <a:schemeClr val="phClr">
-                <a:tint val="45000"/>
-                <a:shade val="99000"/>
-                <a:satMod val="350000"/>
-              </a:schemeClr>
-            </a:gs>
-            <a:gs pos="100000">
-              <a:schemeClr val="phClr">
-                <a:shade val="20000"/>
-                <a:satMod val="255000"/>
-              </a:schemeClr>
-            </a:gs>
-          </a:gsLst>
-          <a:path path="circle">
-            <a:fillToRect l="50000" t="-80000" r="50000" b="180000"/>
-          </a:path>
-        </a:gradFill>
-        <a:gradFill rotWithShape="1">
-          <a:gsLst>
-            <a:gs pos="0">
-              <a:schemeClr val="phClr">
-                <a:tint val="80000"/>
-                <a:satMod val="300000"/>
-              </a:schemeClr>
-            </a:gs>
-            <a:gs pos="100000">
-              <a:schemeClr val="phClr">
-                <a:shade val="30000"/>
-                <a:satMod val="200000"/>
-              </a:schemeClr>
-            </a:gs>
-          </a:gsLst>
-          <a:path path="circle">
-            <a:fillToRect l="50000" t="50000" r="50000" b="50000"/>
-          </a:path>
-        </a:gradFill>
-      </a:bgFillStyleLst>
-    </a:fmtScheme>
-  </a:themeElements>
-  <a:objectDefaults>
-    <a:spDef>
-      <a:spPr/>
-      <a:bodyPr/>
-      <a:lstStyle/>
-      <a:style>
-        <a:lnRef idx="1">
-          <a:schemeClr val="accent1"/>
-        </a:lnRef>
-        <a:fillRef idx="3">
-          <a:schemeClr val="accent1"/>
-        </a:fillRef>
-        <a:effectRef idx="2">
-          <a:schemeClr val="accent1"/>
-        </a:effectRef>
-        <a:fontRef idx="minor">
-          <a:schemeClr val="lt1"/>
-        </a:fontRef>
-      </a:style>
-    </a:spDef>
-    <a:lnDef>
-      <a:spPr/>
-      <a:bodyPr/>
-      <a:lstStyle/>
-      <a:style>
-        <a:lnRef idx="2">
-          <a:schemeClr val="accent1"/>
-        </a:lnRef>
-        <a:fillRef idx="0">
-          <a:schemeClr val="accent1"/>
-        </a:fillRef>
-        <a:effectRef idx="1">
-          <a:schemeClr val="accent1"/>
-        </a:effectRef>
-        <a:fontRef idx="minor">
-          <a:schemeClr val="tx1"/>
-        </a:fontRef>
-      </a:style>
-    </a:lnDef>
-  </a:objectDefaults>
-  <a:extraClrSchemeLst/>
-</a:theme>
 </file>
</xml_diff>